<commit_message>
style(workshop): PPTX 切換為 Claude (Anthropic) 設計風格
- 背景：True Black → Parchment #f5f4ed（羊皮紙暖調）
- 程式碼框底：Near Black → Ivory #faf9f5
- 程式碼框邊：BG_CODE 同色 → Warm Sand #e8e6dc（清晰邊界）
- 主強調：NVIDIA Green → Terracotta #c96442（赤陶品牌色）
- 主文字：Pure White → Anthropic Near Black #141413（暖夜黑）
- 輔助文字：Gray 300/400/500 → Dark Warm / Olive Gray / Stone Gray（暖中性）
- 警告：Yellow 300 → Coral #d97757（赤陶變體）
- 錯誤：Red 500 → Error Crimson #b53333（暖紅）
- 標題字體：Arial → Georgia（仿 Anthropic Serif 書本感）

來源：.claude/ui/claude/DESIGN.md
</commit_message>
<xml_diff>
--- a/workshop/docs/slides/VibeCoding_Workshop.pptx
+++ b/workshop/docs/slides/VibeCoding_Workshop.pptx
@@ -4739,7 +4739,7 @@
     <p:bg>
       <p:bgPr>
         <a:solidFill>
-          <a:srgbClr val="000000"/>
+          <a:srgbClr val="F5F4ED"/>
         </a:solidFill>
         <a:effectLst/>
       </p:bgPr>
@@ -4777,9 +4777,9 @@
             <a:r>
               <a:rPr sz="4400" b="1" i="0">
                 <a:solidFill>
-                  <a:srgbClr val="FFFFFF"/>
-                </a:solidFill>
-                <a:latin typeface="Arial"/>
+                  <a:srgbClr val="141413"/>
+                </a:solidFill>
+                <a:latin typeface="Georgia"/>
               </a:rPr>
               <a:t>VibeCoding 模板實戰 Workshop</a:t>
             </a:r>
@@ -4796,7 +4796,7 @@
             <a:r>
               <a:rPr sz="2200" b="0" i="0">
                 <a:solidFill>
-                  <a:srgbClr val="898989"/>
+                  <a:srgbClr val="5E5D59"/>
                 </a:solidFill>
                 <a:latin typeface="Arial"/>
               </a:rPr>
@@ -4820,7 +4820,7 @@
             <a:avLst/>
           </a:prstGeom>
           <a:solidFill>
-            <a:srgbClr val="76B900"/>
+            <a:srgbClr val="C96442"/>
           </a:solidFill>
           <a:ln>
             <a:noFill/>
@@ -4862,7 +4862,7 @@
     <p:bg>
       <p:bgPr>
         <a:solidFill>
-          <a:srgbClr val="000000"/>
+          <a:srgbClr val="F5F4ED"/>
         </a:solidFill>
         <a:effectLst/>
       </p:bgPr>
@@ -4899,9 +4899,9 @@
             <a:r>
               <a:rPr sz="3200" b="1" i="0">
                 <a:solidFill>
-                  <a:srgbClr val="FFFFFF"/>
-                </a:solidFill>
-                <a:latin typeface="Arial"/>
+                  <a:srgbClr val="141413"/>
+                </a:solidFill>
+                <a:latin typeface="Georgia"/>
               </a:rPr>
               <a:t>agents/ — 專業 AI 同事（14 個）</a:t>
             </a:r>
@@ -4923,7 +4923,7 @@
             <a:avLst/>
           </a:prstGeom>
           <a:solidFill>
-            <a:srgbClr val="76B900"/>
+            <a:srgbClr val="C96442"/>
           </a:solidFill>
           <a:ln>
             <a:noFill/>
@@ -4985,7 +4985,7 @@
             <a:r>
               <a:rPr sz="2000" b="1" i="0">
                 <a:solidFill>
-                  <a:srgbClr val="76B900"/>
+                  <a:srgbClr val="C96442"/>
                 </a:solidFill>
                 <a:latin typeface="Arial"/>
               </a:rPr>
@@ -5004,7 +5004,7 @@
             <a:r>
               <a:rPr sz="1800" b="0" i="0">
                 <a:solidFill>
-                  <a:srgbClr val="A7A7A7"/>
+                  <a:srgbClr val="3D3D3A"/>
                 </a:solidFill>
                 <a:latin typeface="Arial"/>
               </a:rPr>
@@ -5023,7 +5023,7 @@
             <a:r>
               <a:rPr sz="1000" b="0" i="0">
                 <a:solidFill>
-                  <a:srgbClr val="FFFFFF"/>
+                  <a:srgbClr val="141413"/>
                 </a:solidFill>
                 <a:latin typeface="Arial"/>
               </a:rPr>
@@ -5042,7 +5042,7 @@
             <a:r>
               <a:rPr sz="2000" b="1" i="0">
                 <a:solidFill>
-                  <a:srgbClr val="FFFFFF"/>
+                  <a:srgbClr val="141413"/>
                 </a:solidFill>
                 <a:latin typeface="Arial"/>
               </a:rPr>
@@ -5061,7 +5061,7 @@
             <a:r>
               <a:rPr sz="1800" b="0" i="0">
                 <a:solidFill>
-                  <a:srgbClr val="FFFFFF"/>
+                  <a:srgbClr val="141413"/>
                 </a:solidFill>
                 <a:latin typeface="Arial"/>
               </a:rPr>
@@ -5080,7 +5080,7 @@
             <a:r>
               <a:rPr sz="1800" b="0" i="0">
                 <a:solidFill>
-                  <a:srgbClr val="FFFFFF"/>
+                  <a:srgbClr val="141413"/>
                 </a:solidFill>
                 <a:latin typeface="Arial"/>
               </a:rPr>
@@ -5099,7 +5099,7 @@
             <a:r>
               <a:rPr sz="1800" b="0" i="0">
                 <a:solidFill>
-                  <a:srgbClr val="FFFFFF"/>
+                  <a:srgbClr val="141413"/>
                 </a:solidFill>
                 <a:latin typeface="Arial"/>
               </a:rPr>
@@ -5118,7 +5118,7 @@
             <a:r>
               <a:rPr sz="1800" b="0" i="0">
                 <a:solidFill>
-                  <a:srgbClr val="FFFFFF"/>
+                  <a:srgbClr val="141413"/>
                 </a:solidFill>
                 <a:latin typeface="Arial"/>
               </a:rPr>
@@ -5137,7 +5137,7 @@
             <a:r>
               <a:rPr sz="1000" b="0" i="0">
                 <a:solidFill>
-                  <a:srgbClr val="FFFFFF"/>
+                  <a:srgbClr val="141413"/>
                 </a:solidFill>
                 <a:latin typeface="Arial"/>
               </a:rPr>
@@ -5156,7 +5156,7 @@
             <a:r>
               <a:rPr sz="1800" b="1" i="0">
                 <a:solidFill>
-                  <a:srgbClr val="76B900"/>
+                  <a:srgbClr val="6B7A3F"/>
                 </a:solidFill>
                 <a:latin typeface="Arial"/>
               </a:rPr>
@@ -5179,7 +5179,7 @@
     <p:bg>
       <p:bgPr>
         <a:solidFill>
-          <a:srgbClr val="000000"/>
+          <a:srgbClr val="F5F4ED"/>
         </a:solidFill>
         <a:effectLst/>
       </p:bgPr>
@@ -5216,9 +5216,9 @@
             <a:r>
               <a:rPr sz="3200" b="1" i="0">
                 <a:solidFill>
-                  <a:srgbClr val="FFFFFF"/>
-                </a:solidFill>
-                <a:latin typeface="Arial"/>
+                  <a:srgbClr val="141413"/>
+                </a:solidFill>
+                <a:latin typeface="Georgia"/>
               </a:rPr>
               <a:t>skills/ — 領域知識按需載入（7 個）</a:t>
             </a:r>
@@ -5240,7 +5240,7 @@
             <a:avLst/>
           </a:prstGeom>
           <a:solidFill>
-            <a:srgbClr val="76B900"/>
+            <a:srgbClr val="C96442"/>
           </a:solidFill>
           <a:ln>
             <a:noFill/>
@@ -5302,7 +5302,7 @@
             <a:r>
               <a:rPr sz="2000" b="1" i="0">
                 <a:solidFill>
-                  <a:srgbClr val="76B900"/>
+                  <a:srgbClr val="C96442"/>
                 </a:solidFill>
                 <a:latin typeface="Arial"/>
               </a:rPr>
@@ -5321,7 +5321,7 @@
             <a:r>
               <a:rPr sz="1800" b="0" i="0">
                 <a:solidFill>
-                  <a:srgbClr val="A7A7A7"/>
+                  <a:srgbClr val="3D3D3A"/>
                 </a:solidFill>
                 <a:latin typeface="Arial"/>
               </a:rPr>
@@ -5340,7 +5340,7 @@
             <a:r>
               <a:rPr sz="1000" b="0" i="0">
                 <a:solidFill>
-                  <a:srgbClr val="FFFFFF"/>
+                  <a:srgbClr val="141413"/>
                 </a:solidFill>
                 <a:latin typeface="Arial"/>
               </a:rPr>
@@ -5359,7 +5359,7 @@
             <a:r>
               <a:rPr sz="1800" b="0" i="0">
                 <a:solidFill>
-                  <a:srgbClr val="FFFFFF"/>
+                  <a:srgbClr val="141413"/>
                 </a:solidFill>
                 <a:latin typeface="Arial"/>
               </a:rPr>
@@ -5378,7 +5378,7 @@
             <a:r>
               <a:rPr sz="1800" b="0" i="0">
                 <a:solidFill>
-                  <a:srgbClr val="FFFFFF"/>
+                  <a:srgbClr val="141413"/>
                 </a:solidFill>
                 <a:latin typeface="Arial"/>
               </a:rPr>
@@ -5397,7 +5397,7 @@
             <a:r>
               <a:rPr sz="1800" b="0" i="0">
                 <a:solidFill>
-                  <a:srgbClr val="FFFFFF"/>
+                  <a:srgbClr val="141413"/>
                 </a:solidFill>
                 <a:latin typeface="Arial"/>
               </a:rPr>
@@ -5416,7 +5416,7 @@
             <a:r>
               <a:rPr sz="1800" b="0" i="0">
                 <a:solidFill>
-                  <a:srgbClr val="FFFFFF"/>
+                  <a:srgbClr val="141413"/>
                 </a:solidFill>
                 <a:latin typeface="Arial"/>
               </a:rPr>
@@ -5435,7 +5435,7 @@
             <a:r>
               <a:rPr sz="1800" b="0" i="0">
                 <a:solidFill>
-                  <a:srgbClr val="FFFFFF"/>
+                  <a:srgbClr val="141413"/>
                 </a:solidFill>
                 <a:latin typeface="Arial"/>
               </a:rPr>
@@ -5454,7 +5454,7 @@
             <a:r>
               <a:rPr sz="1800" b="0" i="0">
                 <a:solidFill>
-                  <a:srgbClr val="FFFFFF"/>
+                  <a:srgbClr val="141413"/>
                 </a:solidFill>
                 <a:latin typeface="Arial"/>
               </a:rPr>
@@ -5473,7 +5473,7 @@
             <a:r>
               <a:rPr sz="1000" b="0" i="0">
                 <a:solidFill>
-                  <a:srgbClr val="FFFFFF"/>
+                  <a:srgbClr val="141413"/>
                 </a:solidFill>
                 <a:latin typeface="Arial"/>
               </a:rPr>
@@ -5492,7 +5492,7 @@
             <a:r>
               <a:rPr sz="1600" b="0" i="0">
                 <a:solidFill>
-                  <a:srgbClr val="898989"/>
+                  <a:srgbClr val="5E5D59"/>
                 </a:solidFill>
                 <a:latin typeface="Arial"/>
               </a:rPr>
@@ -5515,7 +5515,7 @@
     <p:bg>
       <p:bgPr>
         <a:solidFill>
-          <a:srgbClr val="000000"/>
+          <a:srgbClr val="F5F4ED"/>
         </a:solidFill>
         <a:effectLst/>
       </p:bgPr>
@@ -5552,9 +5552,9 @@
             <a:r>
               <a:rPr sz="3200" b="1" i="0">
                 <a:solidFill>
-                  <a:srgbClr val="FFFFFF"/>
-                </a:solidFill>
-                <a:latin typeface="Arial"/>
+                  <a:srgbClr val="141413"/>
+                </a:solidFill>
+                <a:latin typeface="Georgia"/>
               </a:rPr>
               <a:t>hooks/ — 事件自動化（6 個）</a:t>
             </a:r>
@@ -5576,7 +5576,7 @@
             <a:avLst/>
           </a:prstGeom>
           <a:solidFill>
-            <a:srgbClr val="76B900"/>
+            <a:srgbClr val="C96442"/>
           </a:solidFill>
           <a:ln>
             <a:noFill/>
@@ -5638,7 +5638,7 @@
             <a:r>
               <a:rPr sz="2000" b="1" i="0">
                 <a:solidFill>
-                  <a:srgbClr val="76B900"/>
+                  <a:srgbClr val="C96442"/>
                 </a:solidFill>
                 <a:latin typeface="Arial"/>
               </a:rPr>
@@ -5657,7 +5657,7 @@
             <a:r>
               <a:rPr sz="1800" b="0" i="0">
                 <a:solidFill>
-                  <a:srgbClr val="A7A7A7"/>
+                  <a:srgbClr val="3D3D3A"/>
                 </a:solidFill>
                 <a:latin typeface="Arial"/>
               </a:rPr>
@@ -5676,7 +5676,7 @@
             <a:r>
               <a:rPr sz="1000" b="0" i="0">
                 <a:solidFill>
-                  <a:srgbClr val="FFFFFF"/>
+                  <a:srgbClr val="141413"/>
                 </a:solidFill>
                 <a:latin typeface="Arial"/>
               </a:rPr>
@@ -5695,7 +5695,7 @@
             <a:r>
               <a:rPr sz="2000" b="1" i="0">
                 <a:solidFill>
-                  <a:srgbClr val="FFFFFF"/>
+                  <a:srgbClr val="141413"/>
                 </a:solidFill>
                 <a:latin typeface="Arial"/>
               </a:rPr>
@@ -5714,7 +5714,7 @@
             <a:r>
               <a:rPr sz="1700" b="0" i="0">
                 <a:solidFill>
-                  <a:srgbClr val="FFFFFF"/>
+                  <a:srgbClr val="141413"/>
                 </a:solidFill>
                 <a:latin typeface="Arial"/>
               </a:rPr>
@@ -5733,7 +5733,7 @@
             <a:r>
               <a:rPr sz="1700" b="0" i="0">
                 <a:solidFill>
-                  <a:srgbClr val="FFFFFF"/>
+                  <a:srgbClr val="141413"/>
                 </a:solidFill>
                 <a:latin typeface="Arial"/>
               </a:rPr>
@@ -5752,7 +5752,7 @@
             <a:r>
               <a:rPr sz="1700" b="0" i="0">
                 <a:solidFill>
-                  <a:srgbClr val="FFFFFF"/>
+                  <a:srgbClr val="141413"/>
                 </a:solidFill>
                 <a:latin typeface="Arial"/>
               </a:rPr>
@@ -5771,7 +5771,7 @@
             <a:r>
               <a:rPr sz="1700" b="0" i="0">
                 <a:solidFill>
-                  <a:srgbClr val="FFFFFF"/>
+                  <a:srgbClr val="141413"/>
                 </a:solidFill>
                 <a:latin typeface="Arial"/>
               </a:rPr>
@@ -5790,7 +5790,7 @@
             <a:r>
               <a:rPr sz="1700" b="0" i="0">
                 <a:solidFill>
-                  <a:srgbClr val="FFFFFF"/>
+                  <a:srgbClr val="141413"/>
                 </a:solidFill>
                 <a:latin typeface="Arial"/>
               </a:rPr>
@@ -5809,7 +5809,7 @@
             <a:r>
               <a:rPr sz="1000" b="0" i="0">
                 <a:solidFill>
-                  <a:srgbClr val="FFFFFF"/>
+                  <a:srgbClr val="141413"/>
                 </a:solidFill>
                 <a:latin typeface="Arial"/>
               </a:rPr>
@@ -5828,7 +5828,7 @@
             <a:r>
               <a:rPr sz="1800" b="1" i="0">
                 <a:solidFill>
-                  <a:srgbClr val="76B900"/>
+                  <a:srgbClr val="6B7A3F"/>
                 </a:solidFill>
                 <a:latin typeface="Arial"/>
               </a:rPr>
@@ -5851,7 +5851,7 @@
     <p:bg>
       <p:bgPr>
         <a:solidFill>
-          <a:srgbClr val="000000"/>
+          <a:srgbClr val="F5F4ED"/>
         </a:solidFill>
         <a:effectLst/>
       </p:bgPr>
@@ -5888,9 +5888,9 @@
             <a:r>
               <a:rPr sz="3200" b="1" i="0">
                 <a:solidFill>
-                  <a:srgbClr val="FFFFFF"/>
-                </a:solidFill>
-                <a:latin typeface="Arial"/>
+                  <a:srgbClr val="141413"/>
+                </a:solidFill>
+                <a:latin typeface="Georgia"/>
               </a:rPr>
               <a:t>6 大觀念對照表 — 一張記住差異</a:t>
             </a:r>
@@ -5912,7 +5912,7 @@
             <a:avLst/>
           </a:prstGeom>
           <a:solidFill>
-            <a:srgbClr val="76B900"/>
+            <a:srgbClr val="C96442"/>
           </a:solidFill>
           <a:ln>
             <a:noFill/>
@@ -5974,7 +5974,7 @@
             <a:r>
               <a:rPr sz="1800" b="1" i="0">
                 <a:solidFill>
-                  <a:srgbClr val="76B900"/>
+                  <a:srgbClr val="C96442"/>
                 </a:solidFill>
                 <a:latin typeface="Arial"/>
               </a:rPr>
@@ -5993,7 +5993,7 @@
             <a:r>
               <a:rPr sz="1800" b="0" i="0">
                 <a:solidFill>
-                  <a:srgbClr val="FFFFFF"/>
+                  <a:srgbClr val="141413"/>
                 </a:solidFill>
                 <a:latin typeface="Arial"/>
               </a:rPr>
@@ -6012,7 +6012,7 @@
             <a:r>
               <a:rPr sz="1800" b="0" i="0">
                 <a:solidFill>
-                  <a:srgbClr val="FFFFFF"/>
+                  <a:srgbClr val="141413"/>
                 </a:solidFill>
                 <a:latin typeface="Arial"/>
               </a:rPr>
@@ -6031,7 +6031,7 @@
             <a:r>
               <a:rPr sz="1800" b="0" i="0">
                 <a:solidFill>
-                  <a:srgbClr val="FFFFFF"/>
+                  <a:srgbClr val="141413"/>
                 </a:solidFill>
                 <a:latin typeface="Arial"/>
               </a:rPr>
@@ -6050,7 +6050,7 @@
             <a:r>
               <a:rPr sz="1800" b="0" i="0">
                 <a:solidFill>
-                  <a:srgbClr val="FFFFFF"/>
+                  <a:srgbClr val="141413"/>
                 </a:solidFill>
                 <a:latin typeface="Arial"/>
               </a:rPr>
@@ -6069,7 +6069,7 @@
             <a:r>
               <a:rPr sz="1800" b="0" i="0">
                 <a:solidFill>
-                  <a:srgbClr val="FFFFFF"/>
+                  <a:srgbClr val="141413"/>
                 </a:solidFill>
                 <a:latin typeface="Arial"/>
               </a:rPr>
@@ -6088,7 +6088,7 @@
             <a:r>
               <a:rPr sz="1800" b="0" i="0">
                 <a:solidFill>
-                  <a:srgbClr val="FFFFFF"/>
+                  <a:srgbClr val="141413"/>
                 </a:solidFill>
                 <a:latin typeface="Arial"/>
               </a:rPr>
@@ -6107,7 +6107,7 @@
             <a:r>
               <a:rPr sz="1200" b="0" i="0">
                 <a:solidFill>
-                  <a:srgbClr val="FFFFFF"/>
+                  <a:srgbClr val="141413"/>
                 </a:solidFill>
                 <a:latin typeface="Arial"/>
               </a:rPr>
@@ -6126,7 +6126,7 @@
             <a:r>
               <a:rPr sz="1600" b="0" i="0">
                 <a:solidFill>
-                  <a:srgbClr val="898989"/>
+                  <a:srgbClr val="5E5D59"/>
                 </a:solidFill>
                 <a:latin typeface="Arial"/>
               </a:rPr>
@@ -6149,7 +6149,7 @@
     <p:bg>
       <p:bgPr>
         <a:solidFill>
-          <a:srgbClr val="000000"/>
+          <a:srgbClr val="F5F4ED"/>
         </a:solidFill>
         <a:effectLst/>
       </p:bgPr>
@@ -6186,9 +6186,9 @@
             <a:r>
               <a:rPr sz="3200" b="1" i="0">
                 <a:solidFill>
-                  <a:srgbClr val="FFFFFF"/>
-                </a:solidFill>
-                <a:latin typeface="Arial"/>
+                  <a:srgbClr val="141413"/>
+                </a:solidFill>
+                <a:latin typeface="Georgia"/>
               </a:rPr>
               <a:t>14 個 Agent — 按模型分級</a:t>
             </a:r>
@@ -6210,7 +6210,7 @@
             <a:avLst/>
           </a:prstGeom>
           <a:solidFill>
-            <a:srgbClr val="76B900"/>
+            <a:srgbClr val="C96442"/>
           </a:solidFill>
           <a:ln>
             <a:noFill/>
@@ -6272,7 +6272,7 @@
             <a:r>
               <a:rPr sz="2200" b="1" i="0">
                 <a:solidFill>
-                  <a:srgbClr val="76B900"/>
+                  <a:srgbClr val="C96442"/>
                 </a:solidFill>
                 <a:latin typeface="Arial"/>
               </a:rPr>
@@ -6291,7 +6291,7 @@
             <a:r>
               <a:rPr sz="1800" b="0" i="0">
                 <a:solidFill>
-                  <a:srgbClr val="FFFFFF"/>
+                  <a:srgbClr val="141413"/>
                 </a:solidFill>
                 <a:latin typeface="Arial"/>
               </a:rPr>
@@ -6310,7 +6310,7 @@
             <a:r>
               <a:rPr sz="800" b="0" i="0">
                 <a:solidFill>
-                  <a:srgbClr val="FFFFFF"/>
+                  <a:srgbClr val="141413"/>
                 </a:solidFill>
                 <a:latin typeface="Arial"/>
               </a:rPr>
@@ -6329,7 +6329,7 @@
             <a:r>
               <a:rPr sz="2200" b="1" i="0">
                 <a:solidFill>
-                  <a:srgbClr val="76B900"/>
+                  <a:srgbClr val="6B7A3F"/>
                 </a:solidFill>
                 <a:latin typeface="Arial"/>
               </a:rPr>
@@ -6348,7 +6348,7 @@
             <a:r>
               <a:rPr sz="1800" b="0" i="0">
                 <a:solidFill>
-                  <a:srgbClr val="FFFFFF"/>
+                  <a:srgbClr val="141413"/>
                 </a:solidFill>
                 <a:latin typeface="Arial"/>
               </a:rPr>
@@ -6367,7 +6367,7 @@
             <a:r>
               <a:rPr sz="1800" b="0" i="0">
                 <a:solidFill>
-                  <a:srgbClr val="FFFFFF"/>
+                  <a:srgbClr val="141413"/>
                 </a:solidFill>
                 <a:latin typeface="Arial"/>
               </a:rPr>
@@ -6386,7 +6386,7 @@
             <a:r>
               <a:rPr sz="1800" b="0" i="0">
                 <a:solidFill>
-                  <a:srgbClr val="FFFFFF"/>
+                  <a:srgbClr val="141413"/>
                 </a:solidFill>
                 <a:latin typeface="Arial"/>
               </a:rPr>
@@ -6405,7 +6405,7 @@
             <a:r>
               <a:rPr sz="800" b="0" i="0">
                 <a:solidFill>
-                  <a:srgbClr val="FFFFFF"/>
+                  <a:srgbClr val="141413"/>
                 </a:solidFill>
                 <a:latin typeface="Arial"/>
               </a:rPr>
@@ -6424,7 +6424,7 @@
             <a:r>
               <a:rPr sz="2200" b="1" i="0">
                 <a:solidFill>
-                  <a:srgbClr val="EF9100"/>
+                  <a:srgbClr val="D97757"/>
                 </a:solidFill>
                 <a:latin typeface="Arial"/>
               </a:rPr>
@@ -6443,7 +6443,7 @@
             <a:r>
               <a:rPr sz="1800" b="0" i="0">
                 <a:solidFill>
-                  <a:srgbClr val="FFFFFF"/>
+                  <a:srgbClr val="141413"/>
                 </a:solidFill>
                 <a:latin typeface="Arial"/>
               </a:rPr>
@@ -6462,7 +6462,7 @@
             <a:r>
               <a:rPr sz="800" b="0" i="0">
                 <a:solidFill>
-                  <a:srgbClr val="FFFFFF"/>
+                  <a:srgbClr val="141413"/>
                 </a:solidFill>
                 <a:latin typeface="Arial"/>
               </a:rPr>
@@ -6481,7 +6481,7 @@
             <a:r>
               <a:rPr sz="1600" b="0" i="0">
                 <a:solidFill>
-                  <a:srgbClr val="898989"/>
+                  <a:srgbClr val="5E5D59"/>
                 </a:solidFill>
                 <a:latin typeface="Arial"/>
               </a:rPr>
@@ -6504,7 +6504,7 @@
     <p:bg>
       <p:bgPr>
         <a:solidFill>
-          <a:srgbClr val="000000"/>
+          <a:srgbClr val="F5F4ED"/>
         </a:solidFill>
         <a:effectLst/>
       </p:bgPr>
@@ -6541,9 +6541,9 @@
             <a:r>
               <a:rPr sz="3000" b="1" i="0">
                 <a:solidFill>
-                  <a:srgbClr val="FFFFFF"/>
-                </a:solidFill>
-                <a:latin typeface="Arial"/>
+                  <a:srgbClr val="141413"/>
+                </a:solidFill>
+                <a:latin typeface="Georgia"/>
               </a:rPr>
               <a:t>目錄結構 — .claude/ 下的關鍵目錄</a:t>
             </a:r>
@@ -6565,11 +6565,11 @@
             <a:avLst/>
           </a:prstGeom>
           <a:solidFill>
-            <a:srgbClr val="1A1A1A"/>
+            <a:srgbClr val="FAF9F5"/>
           </a:solidFill>
           <a:ln w="12700">
             <a:solidFill>
-              <a:srgbClr val="1A1A1A"/>
+              <a:srgbClr val="E8E6DC"/>
             </a:solidFill>
           </a:ln>
           <a:effectLst/>
@@ -6629,7 +6629,7 @@
             <a:r>
               <a:rPr sz="1600" b="0" i="0">
                 <a:solidFill>
-                  <a:srgbClr val="76B900"/>
+                  <a:srgbClr val="C96442"/>
                 </a:solidFill>
                 <a:latin typeface="Consolas"/>
               </a:rPr>
@@ -6648,7 +6648,7 @@
             <a:r>
               <a:rPr sz="1600" b="0" i="0">
                 <a:solidFill>
-                  <a:srgbClr val="76B900"/>
+                  <a:srgbClr val="C96442"/>
                 </a:solidFill>
                 <a:latin typeface="Consolas"/>
               </a:rPr>
@@ -6667,7 +6667,7 @@
             <a:r>
               <a:rPr sz="1600" b="0" i="0">
                 <a:solidFill>
-                  <a:srgbClr val="A7A7A7"/>
+                  <a:srgbClr val="3D3D3A"/>
                 </a:solidFill>
                 <a:latin typeface="Consolas"/>
               </a:rPr>
@@ -6686,7 +6686,7 @@
             <a:r>
               <a:rPr sz="1600" b="0" i="0">
                 <a:solidFill>
-                  <a:srgbClr val="A7A7A7"/>
+                  <a:srgbClr val="3D3D3A"/>
                 </a:solidFill>
                 <a:latin typeface="Consolas"/>
               </a:rPr>
@@ -6705,7 +6705,7 @@
             <a:r>
               <a:rPr sz="1600" b="0" i="0">
                 <a:solidFill>
-                  <a:srgbClr val="76B900"/>
+                  <a:srgbClr val="6B7A3F"/>
                 </a:solidFill>
                 <a:latin typeface="Consolas"/>
               </a:rPr>
@@ -6724,7 +6724,7 @@
             <a:r>
               <a:rPr sz="1600" b="0" i="0">
                 <a:solidFill>
-                  <a:srgbClr val="A7A7A7"/>
+                  <a:srgbClr val="3D3D3A"/>
                 </a:solidFill>
                 <a:latin typeface="Consolas"/>
               </a:rPr>
@@ -6743,7 +6743,7 @@
             <a:r>
               <a:rPr sz="1600" b="0" i="0">
                 <a:solidFill>
-                  <a:srgbClr val="A7A7A7"/>
+                  <a:srgbClr val="3D3D3A"/>
                 </a:solidFill>
                 <a:latin typeface="Consolas"/>
               </a:rPr>
@@ -6762,7 +6762,7 @@
             <a:r>
               <a:rPr sz="1600" b="0" i="0">
                 <a:solidFill>
-                  <a:srgbClr val="A7A7A7"/>
+                  <a:srgbClr val="3D3D3A"/>
                 </a:solidFill>
                 <a:latin typeface="Consolas"/>
               </a:rPr>
@@ -6781,7 +6781,7 @@
             <a:r>
               <a:rPr sz="1600" b="0" i="0">
                 <a:solidFill>
-                  <a:srgbClr val="A7A7A7"/>
+                  <a:srgbClr val="3D3D3A"/>
                 </a:solidFill>
                 <a:latin typeface="Consolas"/>
               </a:rPr>
@@ -6800,7 +6800,7 @@
             <a:r>
               <a:rPr sz="1600" b="0" i="0">
                 <a:solidFill>
-                  <a:srgbClr val="757575"/>
+                  <a:srgbClr val="87867F"/>
                 </a:solidFill>
                 <a:latin typeface="Consolas"/>
               </a:rPr>
@@ -6819,7 +6819,7 @@
             <a:r>
               <a:rPr sz="1600" b="0" i="0">
                 <a:solidFill>
-                  <a:srgbClr val="76B900"/>
+                  <a:srgbClr val="C96442"/>
                 </a:solidFill>
                 <a:latin typeface="Consolas"/>
               </a:rPr>
@@ -6842,7 +6842,7 @@
     <p:bg>
       <p:bgPr>
         <a:solidFill>
-          <a:srgbClr val="000000"/>
+          <a:srgbClr val="F5F4ED"/>
         </a:solidFill>
         <a:effectLst/>
       </p:bgPr>
@@ -6879,9 +6879,9 @@
             <a:r>
               <a:rPr sz="3200" b="1" i="0">
                 <a:solidFill>
-                  <a:srgbClr val="FFFFFF"/>
-                </a:solidFill>
-                <a:latin typeface="Arial"/>
+                  <a:srgbClr val="141413"/>
+                </a:solidFill>
+                <a:latin typeface="Georgia"/>
               </a:rPr>
               <a:t>環境準備檢查</a:t>
             </a:r>
@@ -6903,7 +6903,7 @@
             <a:avLst/>
           </a:prstGeom>
           <a:solidFill>
-            <a:srgbClr val="76B900"/>
+            <a:srgbClr val="C96442"/>
           </a:solidFill>
           <a:ln>
             <a:noFill/>
@@ -6965,7 +6965,7 @@
             <a:r>
               <a:rPr sz="2200" b="0" i="0">
                 <a:solidFill>
-                  <a:srgbClr val="A7A7A7"/>
+                  <a:srgbClr val="3D3D3A"/>
                 </a:solidFill>
                 <a:latin typeface="Arial"/>
               </a:rPr>
@@ -6984,7 +6984,7 @@
             <a:r>
               <a:rPr sz="2200" b="0" i="0">
                 <a:solidFill>
-                  <a:srgbClr val="A7A7A7"/>
+                  <a:srgbClr val="3D3D3A"/>
                 </a:solidFill>
                 <a:latin typeface="Arial"/>
               </a:rPr>
@@ -7003,7 +7003,7 @@
             <a:r>
               <a:rPr sz="2200" b="0" i="0">
                 <a:solidFill>
-                  <a:srgbClr val="A7A7A7"/>
+                  <a:srgbClr val="3D3D3A"/>
                 </a:solidFill>
                 <a:latin typeface="Arial"/>
               </a:rPr>
@@ -7022,7 +7022,7 @@
             <a:r>
               <a:rPr sz="2200" b="0" i="0">
                 <a:solidFill>
-                  <a:srgbClr val="A7A7A7"/>
+                  <a:srgbClr val="3D3D3A"/>
                 </a:solidFill>
                 <a:latin typeface="Arial"/>
               </a:rPr>
@@ -7041,7 +7041,7 @@
             <a:r>
               <a:rPr sz="2200" b="0" i="0">
                 <a:solidFill>
-                  <a:srgbClr val="A7A7A7"/>
+                  <a:srgbClr val="3D3D3A"/>
                 </a:solidFill>
                 <a:latin typeface="Arial"/>
               </a:rPr>
@@ -7060,7 +7060,7 @@
             <a:r>
               <a:rPr sz="2200" b="0" i="0">
                 <a:solidFill>
-                  <a:srgbClr val="A7A7A7"/>
+                  <a:srgbClr val="3D3D3A"/>
                 </a:solidFill>
                 <a:latin typeface="Arial"/>
               </a:rPr>
@@ -7083,7 +7083,7 @@
     <p:bg>
       <p:bgPr>
         <a:solidFill>
-          <a:srgbClr val="000000"/>
+          <a:srgbClr val="F5F4ED"/>
         </a:solidFill>
         <a:effectLst/>
       </p:bgPr>
@@ -7120,9 +7120,9 @@
             <a:r>
               <a:rPr sz="3200" b="1" i="0">
                 <a:solidFill>
-                  <a:srgbClr val="FFFFFF"/>
-                </a:solidFill>
-                <a:latin typeface="Arial"/>
+                  <a:srgbClr val="141413"/>
+                </a:solidFill>
+                <a:latin typeface="Georgia"/>
               </a:rPr>
               <a:t>今天的旅程</a:t>
             </a:r>
@@ -7144,7 +7144,7 @@
             <a:avLst/>
           </a:prstGeom>
           <a:solidFill>
-            <a:srgbClr val="76B900"/>
+            <a:srgbClr val="C96442"/>
           </a:solidFill>
           <a:ln>
             <a:noFill/>
@@ -7206,7 +7206,7 @@
             <a:r>
               <a:rPr sz="2200" b="1" i="0">
                 <a:solidFill>
-                  <a:srgbClr val="76B900"/>
+                  <a:srgbClr val="C96442"/>
                 </a:solidFill>
                 <a:latin typeface="Arial"/>
               </a:rPr>
@@ -7225,7 +7225,7 @@
             <a:r>
               <a:rPr sz="2200" b="0" i="0">
                 <a:solidFill>
-                  <a:srgbClr val="FFFFFF"/>
+                  <a:srgbClr val="141413"/>
                 </a:solidFill>
                 <a:latin typeface="Arial"/>
               </a:rPr>
@@ -7244,7 +7244,7 @@
             <a:r>
               <a:rPr sz="2200" b="1" i="0">
                 <a:solidFill>
-                  <a:srgbClr val="EF9100"/>
+                  <a:srgbClr val="D97757"/>
                 </a:solidFill>
                 <a:latin typeface="Arial"/>
               </a:rPr>
@@ -7263,7 +7263,7 @@
             <a:r>
               <a:rPr sz="2200" b="0" i="0">
                 <a:solidFill>
-                  <a:srgbClr val="FFFFFF"/>
+                  <a:srgbClr val="141413"/>
                 </a:solidFill>
                 <a:latin typeface="Arial"/>
               </a:rPr>
@@ -7282,7 +7282,7 @@
             <a:r>
               <a:rPr sz="2200" b="0" i="0">
                 <a:solidFill>
-                  <a:srgbClr val="FFFFFF"/>
+                  <a:srgbClr val="141413"/>
                 </a:solidFill>
                 <a:latin typeface="Arial"/>
               </a:rPr>
@@ -7301,7 +7301,7 @@
             <a:r>
               <a:rPr sz="1200" b="0" i="0">
                 <a:solidFill>
-                  <a:srgbClr val="FFFFFF"/>
+                  <a:srgbClr val="141413"/>
                 </a:solidFill>
                 <a:latin typeface="Arial"/>
               </a:rPr>
@@ -7320,7 +7320,7 @@
             <a:r>
               <a:rPr sz="2000" b="1" i="0">
                 <a:solidFill>
-                  <a:srgbClr val="76B900"/>
+                  <a:srgbClr val="6B7A3F"/>
                 </a:solidFill>
                 <a:latin typeface="Arial"/>
               </a:rPr>
@@ -7343,7 +7343,7 @@
     <p:bg>
       <p:bgPr>
         <a:solidFill>
-          <a:srgbClr val="000000"/>
+          <a:srgbClr val="F5F4ED"/>
         </a:solidFill>
         <a:effectLst/>
       </p:bgPr>
@@ -7381,7 +7381,7 @@
             <a:r>
               <a:rPr sz="2000" b="0" i="0">
                 <a:solidFill>
-                  <a:srgbClr val="76B900"/>
+                  <a:srgbClr val="C96442"/>
                 </a:solidFill>
                 <a:latin typeface="Arial"/>
               </a:rPr>
@@ -7416,9 +7416,9 @@
             <a:r>
               <a:rPr sz="4000" b="1" i="0">
                 <a:solidFill>
-                  <a:srgbClr val="FFFFFF"/>
-                </a:solidFill>
-                <a:latin typeface="Arial"/>
+                  <a:srgbClr val="141413"/>
+                </a:solidFill>
+                <a:latin typeface="Georgia"/>
               </a:rPr>
               <a:t>專案初始化</a:t>
             </a:r>
@@ -7439,7 +7439,7 @@
     <p:bg>
       <p:bgPr>
         <a:solidFill>
-          <a:srgbClr val="000000"/>
+          <a:srgbClr val="F5F4ED"/>
         </a:solidFill>
         <a:effectLst/>
       </p:bgPr>
@@ -7476,9 +7476,9 @@
             <a:r>
               <a:rPr sz="3200" b="1" i="0">
                 <a:solidFill>
-                  <a:srgbClr val="FFFFFF"/>
-                </a:solidFill>
-                <a:latin typeface="Arial"/>
+                  <a:srgbClr val="141413"/>
+                </a:solidFill>
+                <a:latin typeface="Georgia"/>
               </a:rPr>
               <a:t>一切從 /task-init 開始</a:t>
             </a:r>
@@ -7500,7 +7500,7 @@
             <a:avLst/>
           </a:prstGeom>
           <a:solidFill>
-            <a:srgbClr val="76B900"/>
+            <a:srgbClr val="C96442"/>
           </a:solidFill>
           <a:ln>
             <a:noFill/>
@@ -7562,7 +7562,7 @@
             <a:r>
               <a:rPr sz="2400" b="1" i="0">
                 <a:solidFill>
-                  <a:srgbClr val="76B900"/>
+                  <a:srgbClr val="C96442"/>
                 </a:solidFill>
                 <a:latin typeface="Arial"/>
               </a:rPr>
@@ -7581,7 +7581,7 @@
             <a:r>
               <a:rPr sz="800" b="0" i="0">
                 <a:solidFill>
-                  <a:srgbClr val="FFFFFF"/>
+                  <a:srgbClr val="141413"/>
                 </a:solidFill>
                 <a:latin typeface="Arial"/>
               </a:rPr>
@@ -7600,7 +7600,7 @@
             <a:r>
               <a:rPr sz="2000" b="1" i="0">
                 <a:solidFill>
-                  <a:srgbClr val="FFFFFF"/>
+                  <a:srgbClr val="141413"/>
                 </a:solidFill>
                 <a:latin typeface="Arial"/>
               </a:rPr>
@@ -7619,7 +7619,7 @@
             <a:r>
               <a:rPr sz="2000" b="0" i="0">
                 <a:solidFill>
-                  <a:srgbClr val="FFFFFF"/>
+                  <a:srgbClr val="141413"/>
                 </a:solidFill>
                 <a:latin typeface="Arial"/>
               </a:rPr>
@@ -7638,7 +7638,7 @@
             <a:r>
               <a:rPr sz="1600" b="0" i="0">
                 <a:solidFill>
-                  <a:srgbClr val="898989"/>
+                  <a:srgbClr val="5E5D59"/>
                 </a:solidFill>
                 <a:latin typeface="Arial"/>
               </a:rPr>
@@ -7657,7 +7657,7 @@
             <a:r>
               <a:rPr sz="2000" b="0" i="0">
                 <a:solidFill>
-                  <a:srgbClr val="FFFFFF"/>
+                  <a:srgbClr val="141413"/>
                 </a:solidFill>
                 <a:latin typeface="Arial"/>
               </a:rPr>
@@ -7676,7 +7676,7 @@
             <a:r>
               <a:rPr sz="1800" b="0" i="0">
                 <a:solidFill>
-                  <a:srgbClr val="76B900"/>
+                  <a:srgbClr val="6B7A3F"/>
                 </a:solidFill>
                 <a:latin typeface="Arial"/>
               </a:rPr>
@@ -7695,7 +7695,7 @@
             <a:r>
               <a:rPr sz="1800" b="0" i="0">
                 <a:solidFill>
-                  <a:srgbClr val="76B900"/>
+                  <a:srgbClr val="6B7A3F"/>
                 </a:solidFill>
                 <a:latin typeface="Arial"/>
               </a:rPr>
@@ -7714,7 +7714,7 @@
             <a:r>
               <a:rPr sz="2000" b="0" i="0">
                 <a:solidFill>
-                  <a:srgbClr val="FFFFFF"/>
+                  <a:srgbClr val="141413"/>
                 </a:solidFill>
                 <a:latin typeface="Arial"/>
               </a:rPr>
@@ -7737,7 +7737,7 @@
     <p:bg>
       <p:bgPr>
         <a:solidFill>
-          <a:srgbClr val="000000"/>
+          <a:srgbClr val="F5F4ED"/>
         </a:solidFill>
         <a:effectLst/>
       </p:bgPr>
@@ -7775,7 +7775,7 @@
             <a:r>
               <a:rPr sz="2000" b="0" i="0">
                 <a:solidFill>
-                  <a:srgbClr val="76B900"/>
+                  <a:srgbClr val="C96442"/>
                 </a:solidFill>
                 <a:latin typeface="Arial"/>
               </a:rPr>
@@ -7810,9 +7810,9 @@
             <a:r>
               <a:rPr sz="4000" b="1" i="0">
                 <a:solidFill>
-                  <a:srgbClr val="FFFFFF"/>
-                </a:solidFill>
-                <a:latin typeface="Arial"/>
+                  <a:srgbClr val="141413"/>
+                </a:solidFill>
+                <a:latin typeface="Georgia"/>
               </a:rPr>
               <a:t>認識 VibeCoding 模板</a:t>
             </a:r>
@@ -7833,7 +7833,7 @@
     <p:bg>
       <p:bgPr>
         <a:solidFill>
-          <a:srgbClr val="000000"/>
+          <a:srgbClr val="F5F4ED"/>
         </a:solidFill>
         <a:effectLst/>
       </p:bgPr>
@@ -7870,9 +7870,9 @@
             <a:r>
               <a:rPr sz="3200" b="1" i="0">
                 <a:solidFill>
-                  <a:srgbClr val="FFFFFF"/>
-                </a:solidFill>
-                <a:latin typeface="Arial"/>
+                  <a:srgbClr val="141413"/>
+                </a:solidFill>
+                <a:latin typeface="Georgia"/>
               </a:rPr>
               <a:t>MVP vs Complete 模式</a:t>
             </a:r>
@@ -7894,7 +7894,7 @@
             <a:avLst/>
           </a:prstGeom>
           <a:solidFill>
-            <a:srgbClr val="76B900"/>
+            <a:srgbClr val="C96442"/>
           </a:solidFill>
           <a:ln>
             <a:noFill/>
@@ -7947,7 +7947,7 @@
             <a:r>
               <a:rPr sz="2200" b="1" i="0">
                 <a:solidFill>
-                  <a:srgbClr val="76B900"/>
+                  <a:srgbClr val="C96442"/>
                 </a:solidFill>
                 <a:latin typeface="Arial"/>
               </a:rPr>
@@ -7966,7 +7966,7 @@
             <a:r>
               <a:rPr sz="1800" b="0" i="0">
                 <a:solidFill>
-                  <a:srgbClr val="FFFFFF"/>
+                  <a:srgbClr val="141413"/>
                 </a:solidFill>
                 <a:latin typeface="Arial"/>
               </a:rPr>
@@ -7985,7 +7985,7 @@
             <a:r>
               <a:rPr sz="1800" b="0" i="0">
                 <a:solidFill>
-                  <a:srgbClr val="FFFFFF"/>
+                  <a:srgbClr val="141413"/>
                 </a:solidFill>
                 <a:latin typeface="Arial"/>
               </a:rPr>
@@ -8004,7 +8004,7 @@
             <a:r>
               <a:rPr sz="1800" b="0" i="0">
                 <a:solidFill>
-                  <a:srgbClr val="FFFFFF"/>
+                  <a:srgbClr val="141413"/>
                 </a:solidFill>
                 <a:latin typeface="Arial"/>
               </a:rPr>
@@ -8023,7 +8023,7 @@
             <a:r>
               <a:rPr sz="1800" b="0" i="0">
                 <a:solidFill>
-                  <a:srgbClr val="FFFFFF"/>
+                  <a:srgbClr val="141413"/>
                 </a:solidFill>
                 <a:latin typeface="Arial"/>
               </a:rPr>
@@ -8042,7 +8042,7 @@
             <a:r>
               <a:rPr sz="1800" b="0" i="0">
                 <a:solidFill>
-                  <a:srgbClr val="FFFFFF"/>
+                  <a:srgbClr val="141413"/>
                 </a:solidFill>
                 <a:latin typeface="Arial"/>
               </a:rPr>
@@ -8061,7 +8061,7 @@
             <a:r>
               <a:rPr sz="1800" b="0" i="0">
                 <a:solidFill>
-                  <a:srgbClr val="898989"/>
+                  <a:srgbClr val="5E5D59"/>
                 </a:solidFill>
                 <a:latin typeface="Arial"/>
               </a:rPr>
@@ -8095,7 +8095,7 @@
             <a:r>
               <a:rPr sz="2200" b="1" i="0">
                 <a:solidFill>
-                  <a:srgbClr val="76B900"/>
+                  <a:srgbClr val="6B7A3F"/>
                 </a:solidFill>
                 <a:latin typeface="Arial"/>
               </a:rPr>
@@ -8114,7 +8114,7 @@
             <a:r>
               <a:rPr sz="1800" b="0" i="0">
                 <a:solidFill>
-                  <a:srgbClr val="FFFFFF"/>
+                  <a:srgbClr val="141413"/>
                 </a:solidFill>
                 <a:latin typeface="Arial"/>
               </a:rPr>
@@ -8133,7 +8133,7 @@
             <a:r>
               <a:rPr sz="1800" b="0" i="0">
                 <a:solidFill>
-                  <a:srgbClr val="FFFFFF"/>
+                  <a:srgbClr val="141413"/>
                 </a:solidFill>
                 <a:latin typeface="Arial"/>
               </a:rPr>
@@ -8152,7 +8152,7 @@
             <a:r>
               <a:rPr sz="1800" b="0" i="0">
                 <a:solidFill>
-                  <a:srgbClr val="FFFFFF"/>
+                  <a:srgbClr val="141413"/>
                 </a:solidFill>
                 <a:latin typeface="Arial"/>
               </a:rPr>
@@ -8171,7 +8171,7 @@
             <a:r>
               <a:rPr sz="1800" b="0" i="0">
                 <a:solidFill>
-                  <a:srgbClr val="FFFFFF"/>
+                  <a:srgbClr val="141413"/>
                 </a:solidFill>
                 <a:latin typeface="Arial"/>
               </a:rPr>
@@ -8190,7 +8190,7 @@
             <a:r>
               <a:rPr sz="1800" b="0" i="0">
                 <a:solidFill>
-                  <a:srgbClr val="FFFFFF"/>
+                  <a:srgbClr val="141413"/>
                 </a:solidFill>
                 <a:latin typeface="Arial"/>
               </a:rPr>
@@ -8209,7 +8209,7 @@
             <a:r>
               <a:rPr sz="1800" b="0" i="0">
                 <a:solidFill>
-                  <a:srgbClr val="898989"/>
+                  <a:srgbClr val="5E5D59"/>
                 </a:solidFill>
                 <a:latin typeface="Arial"/>
               </a:rPr>
@@ -8232,7 +8232,7 @@
     <p:bg>
       <p:bgPr>
         <a:solidFill>
-          <a:srgbClr val="000000"/>
+          <a:srgbClr val="F5F4ED"/>
         </a:solidFill>
         <a:effectLst/>
       </p:bgPr>
@@ -8269,9 +8269,9 @@
             <a:r>
               <a:rPr sz="3200" b="1" i="0">
                 <a:solidFill>
-                  <a:srgbClr val="FFFFFF"/>
-                </a:solidFill>
-                <a:latin typeface="Arial"/>
+                  <a:srgbClr val="141413"/>
+                </a:solidFill>
+                <a:latin typeface="Georgia"/>
               </a:rPr>
               <a:t>CLAUDE.md = 專案的「身分證」</a:t>
             </a:r>
@@ -8293,7 +8293,7 @@
             <a:avLst/>
           </a:prstGeom>
           <a:solidFill>
-            <a:srgbClr val="76B900"/>
+            <a:srgbClr val="C96442"/>
           </a:solidFill>
           <a:ln>
             <a:noFill/>
@@ -8355,7 +8355,7 @@
             <a:r>
               <a:rPr sz="2000" b="1" i="0">
                 <a:solidFill>
-                  <a:srgbClr val="76B900"/>
+                  <a:srgbClr val="C96442"/>
                 </a:solidFill>
                 <a:latin typeface="Arial"/>
               </a:rPr>
@@ -8374,7 +8374,7 @@
             <a:r>
               <a:rPr sz="800" b="0" i="0">
                 <a:solidFill>
-                  <a:srgbClr val="FFFFFF"/>
+                  <a:srgbClr val="141413"/>
                 </a:solidFill>
                 <a:latin typeface="Arial"/>
               </a:rPr>
@@ -8393,7 +8393,7 @@
             <a:r>
               <a:rPr sz="2000" b="0" i="0">
                 <a:solidFill>
-                  <a:srgbClr val="FFFFFF"/>
+                  <a:srgbClr val="141413"/>
                 </a:solidFill>
                 <a:latin typeface="Arial"/>
               </a:rPr>
@@ -8412,7 +8412,7 @@
             <a:r>
               <a:rPr sz="2000" b="0" i="0">
                 <a:solidFill>
-                  <a:srgbClr val="FFFFFF"/>
+                  <a:srgbClr val="141413"/>
                 </a:solidFill>
                 <a:latin typeface="Arial"/>
               </a:rPr>
@@ -8431,7 +8431,7 @@
             <a:r>
               <a:rPr sz="2000" b="0" i="0">
                 <a:solidFill>
-                  <a:srgbClr val="FFFFFF"/>
+                  <a:srgbClr val="141413"/>
                 </a:solidFill>
                 <a:latin typeface="Arial"/>
               </a:rPr>
@@ -8450,7 +8450,7 @@
             <a:r>
               <a:rPr sz="2000" b="0" i="0">
                 <a:solidFill>
-                  <a:srgbClr val="FFFFFF"/>
+                  <a:srgbClr val="141413"/>
                 </a:solidFill>
                 <a:latin typeface="Arial"/>
               </a:rPr>
@@ -8469,7 +8469,7 @@
             <a:r>
               <a:rPr sz="2000" b="0" i="0">
                 <a:solidFill>
-                  <a:srgbClr val="FFFFFF"/>
+                  <a:srgbClr val="141413"/>
                 </a:solidFill>
                 <a:latin typeface="Arial"/>
               </a:rPr>
@@ -8488,7 +8488,7 @@
             <a:r>
               <a:rPr sz="1200" b="0" i="0">
                 <a:solidFill>
-                  <a:srgbClr val="FFFFFF"/>
+                  <a:srgbClr val="141413"/>
                 </a:solidFill>
                 <a:latin typeface="Arial"/>
               </a:rPr>
@@ -8507,7 +8507,7 @@
             <a:r>
               <a:rPr sz="2000" b="0" i="0">
                 <a:solidFill>
-                  <a:srgbClr val="76B900"/>
+                  <a:srgbClr val="6B7A3F"/>
                 </a:solidFill>
                 <a:latin typeface="Arial"/>
               </a:rPr>
@@ -8526,7 +8526,7 @@
             <a:r>
               <a:rPr sz="2000" b="0" i="0">
                 <a:solidFill>
-                  <a:srgbClr val="76B900"/>
+                  <a:srgbClr val="6B7A3F"/>
                 </a:solidFill>
                 <a:latin typeface="Arial"/>
               </a:rPr>
@@ -8549,7 +8549,7 @@
     <p:bg>
       <p:bgPr>
         <a:solidFill>
-          <a:srgbClr val="000000"/>
+          <a:srgbClr val="F5F4ED"/>
         </a:solidFill>
         <a:effectLst/>
       </p:bgPr>
@@ -8586,9 +8586,9 @@
             <a:r>
               <a:rPr sz="3000" b="1" i="0">
                 <a:solidFill>
-                  <a:srgbClr val="FFFFFF"/>
-                </a:solidFill>
-                <a:latin typeface="Arial"/>
+                  <a:srgbClr val="141413"/>
+                </a:solidFill>
+                <a:latin typeface="Georgia"/>
               </a:rPr>
               <a:t>WBS = 自動拆解的任務清單</a:t>
             </a:r>
@@ -8610,11 +8610,11 @@
             <a:avLst/>
           </a:prstGeom>
           <a:solidFill>
-            <a:srgbClr val="1A1A1A"/>
+            <a:srgbClr val="FAF9F5"/>
           </a:solidFill>
           <a:ln w="12700">
             <a:solidFill>
-              <a:srgbClr val="1A1A1A"/>
+              <a:srgbClr val="E8E6DC"/>
             </a:solidFill>
           </a:ln>
           <a:effectLst/>
@@ -8674,7 +8674,7 @@
             <a:r>
               <a:rPr sz="1600" b="0" i="0">
                 <a:solidFill>
-                  <a:srgbClr val="76B900"/>
+                  <a:srgbClr val="C96442"/>
                 </a:solidFill>
                 <a:latin typeface="Consolas"/>
               </a:rPr>
@@ -8693,7 +8693,7 @@
             <a:r>
               <a:rPr sz="1600" b="0" i="0">
                 <a:solidFill>
-                  <a:srgbClr val="A7A7A7"/>
+                  <a:srgbClr val="3D3D3A"/>
                 </a:solidFill>
                 <a:latin typeface="Consolas"/>
               </a:rPr>
@@ -8712,7 +8712,7 @@
             <a:r>
               <a:rPr sz="1600" b="0" i="0">
                 <a:solidFill>
-                  <a:srgbClr val="A7A7A7"/>
+                  <a:srgbClr val="3D3D3A"/>
                 </a:solidFill>
                 <a:latin typeface="Consolas"/>
               </a:rPr>
@@ -8731,7 +8731,7 @@
             <a:r>
               <a:rPr sz="1600" b="0" i="0">
                 <a:solidFill>
-                  <a:srgbClr val="757575"/>
+                  <a:srgbClr val="87867F"/>
                 </a:solidFill>
                 <a:latin typeface="Consolas"/>
               </a:rPr>
@@ -8750,7 +8750,7 @@
             <a:r>
               <a:rPr sz="1600" b="0" i="0">
                 <a:solidFill>
-                  <a:srgbClr val="76B900"/>
+                  <a:srgbClr val="C96442"/>
                 </a:solidFill>
                 <a:latin typeface="Consolas"/>
               </a:rPr>
@@ -8769,7 +8769,7 @@
             <a:r>
               <a:rPr sz="1600" b="0" i="0">
                 <a:solidFill>
-                  <a:srgbClr val="76B900"/>
+                  <a:srgbClr val="6B7A3F"/>
                 </a:solidFill>
                 <a:latin typeface="Consolas"/>
               </a:rPr>
@@ -8788,7 +8788,7 @@
             <a:r>
               <a:rPr sz="1600" b="0" i="0">
                 <a:solidFill>
-                  <a:srgbClr val="A7A7A7"/>
+                  <a:srgbClr val="3D3D3A"/>
                 </a:solidFill>
                 <a:latin typeface="Consolas"/>
               </a:rPr>
@@ -8807,7 +8807,7 @@
             <a:r>
               <a:rPr sz="1600" b="0" i="0">
                 <a:solidFill>
-                  <a:srgbClr val="A7A7A7"/>
+                  <a:srgbClr val="3D3D3A"/>
                 </a:solidFill>
                 <a:latin typeface="Consolas"/>
               </a:rPr>
@@ -8826,7 +8826,7 @@
             <a:r>
               <a:rPr sz="1600" b="0" i="0">
                 <a:solidFill>
-                  <a:srgbClr val="757575"/>
+                  <a:srgbClr val="87867F"/>
                 </a:solidFill>
                 <a:latin typeface="Consolas"/>
               </a:rPr>
@@ -8845,7 +8845,7 @@
             <a:r>
               <a:rPr sz="1600" b="0" i="0">
                 <a:solidFill>
-                  <a:srgbClr val="76B900"/>
+                  <a:srgbClr val="C96442"/>
                 </a:solidFill>
                 <a:latin typeface="Consolas"/>
               </a:rPr>
@@ -8864,7 +8864,7 @@
             <a:r>
               <a:rPr sz="1600" b="0" i="0">
                 <a:solidFill>
-                  <a:srgbClr val="A7A7A7"/>
+                  <a:srgbClr val="3D3D3A"/>
                 </a:solidFill>
                 <a:latin typeface="Consolas"/>
               </a:rPr>
@@ -8883,7 +8883,7 @@
             <a:r>
               <a:rPr sz="1600" b="0" i="0">
                 <a:solidFill>
-                  <a:srgbClr val="A7A7A7"/>
+                  <a:srgbClr val="3D3D3A"/>
                 </a:solidFill>
                 <a:latin typeface="Consolas"/>
               </a:rPr>
@@ -8902,7 +8902,7 @@
             <a:r>
               <a:rPr sz="1600" b="0" i="0">
                 <a:solidFill>
-                  <a:srgbClr val="757575"/>
+                  <a:srgbClr val="87867F"/>
                 </a:solidFill>
                 <a:latin typeface="Consolas"/>
               </a:rPr>
@@ -8921,7 +8921,7 @@
             <a:r>
               <a:rPr sz="1600" b="0" i="0">
                 <a:solidFill>
-                  <a:srgbClr val="898989"/>
+                  <a:srgbClr val="5E5D59"/>
                 </a:solidFill>
                 <a:latin typeface="Consolas"/>
               </a:rPr>
@@ -8944,7 +8944,7 @@
     <p:bg>
       <p:bgPr>
         <a:solidFill>
-          <a:srgbClr val="000000"/>
+          <a:srgbClr val="F5F4ED"/>
         </a:solidFill>
         <a:effectLst/>
       </p:bgPr>
@@ -8981,9 +8981,9 @@
             <a:r>
               <a:rPr sz="3000" b="1" i="0">
                 <a:solidFill>
-                  <a:srgbClr val="FFFFFF"/>
-                </a:solidFill>
-                <a:latin typeface="Arial"/>
+                  <a:srgbClr val="141413"/>
+                </a:solidFill>
+                <a:latin typeface="Georgia"/>
               </a:rPr>
               <a:t>⚡ 現場操作 — /task-init</a:t>
             </a:r>
@@ -9005,11 +9005,11 @@
             <a:avLst/>
           </a:prstGeom>
           <a:solidFill>
-            <a:srgbClr val="1A1A1A"/>
+            <a:srgbClr val="FAF9F5"/>
           </a:solidFill>
           <a:ln w="12700">
             <a:solidFill>
-              <a:srgbClr val="1A1A1A"/>
+              <a:srgbClr val="E8E6DC"/>
             </a:solidFill>
           </a:ln>
           <a:effectLst/>
@@ -9069,7 +9069,7 @@
             <a:r>
               <a:rPr sz="1600" b="0" i="0">
                 <a:solidFill>
-                  <a:srgbClr val="898989"/>
+                  <a:srgbClr val="5E5D59"/>
                 </a:solidFill>
                 <a:latin typeface="Consolas"/>
               </a:rPr>
@@ -9088,7 +9088,7 @@
             <a:r>
               <a:rPr sz="1600" b="0" i="0">
                 <a:solidFill>
-                  <a:srgbClr val="FFFFFF"/>
+                  <a:srgbClr val="141413"/>
                 </a:solidFill>
                 <a:latin typeface="Consolas"/>
               </a:rPr>
@@ -9107,7 +9107,7 @@
             <a:r>
               <a:rPr sz="1600" b="0" i="0">
                 <a:solidFill>
-                  <a:srgbClr val="76B900"/>
+                  <a:srgbClr val="C96442"/>
                 </a:solidFill>
                 <a:latin typeface="Consolas"/>
               </a:rPr>
@@ -9126,7 +9126,7 @@
             <a:r>
               <a:rPr sz="1600" b="0" i="0">
                 <a:solidFill>
-                  <a:srgbClr val="757575"/>
+                  <a:srgbClr val="87867F"/>
                 </a:solidFill>
                 <a:latin typeface="Consolas"/>
               </a:rPr>
@@ -9145,7 +9145,7 @@
             <a:r>
               <a:rPr sz="1600" b="0" i="0">
                 <a:solidFill>
-                  <a:srgbClr val="898989"/>
+                  <a:srgbClr val="5E5D59"/>
                 </a:solidFill>
                 <a:latin typeface="Consolas"/>
               </a:rPr>
@@ -9164,7 +9164,7 @@
             <a:r>
               <a:rPr sz="1600" b="0" i="0">
                 <a:solidFill>
-                  <a:srgbClr val="76B900"/>
+                  <a:srgbClr val="C96442"/>
                 </a:solidFill>
                 <a:latin typeface="Consolas"/>
               </a:rPr>
@@ -9183,7 +9183,7 @@
             <a:r>
               <a:rPr sz="1600" b="0" i="0">
                 <a:solidFill>
-                  <a:srgbClr val="757575"/>
+                  <a:srgbClr val="87867F"/>
                 </a:solidFill>
                 <a:latin typeface="Consolas"/>
               </a:rPr>
@@ -9202,7 +9202,7 @@
             <a:r>
               <a:rPr sz="1600" b="0" i="0">
                 <a:solidFill>
-                  <a:srgbClr val="898989"/>
+                  <a:srgbClr val="5E5D59"/>
                 </a:solidFill>
                 <a:latin typeface="Consolas"/>
               </a:rPr>
@@ -9221,7 +9221,7 @@
             <a:r>
               <a:rPr sz="1600" b="0" i="0">
                 <a:solidFill>
-                  <a:srgbClr val="FFFFFF"/>
+                  <a:srgbClr val="141413"/>
                 </a:solidFill>
                 <a:latin typeface="Consolas"/>
               </a:rPr>
@@ -9240,7 +9240,7 @@
             <a:r>
               <a:rPr sz="1600" b="0" i="0">
                 <a:solidFill>
-                  <a:srgbClr val="FFFFFF"/>
+                  <a:srgbClr val="141413"/>
                 </a:solidFill>
                 <a:latin typeface="Consolas"/>
               </a:rPr>
@@ -9259,7 +9259,7 @@
             <a:r>
               <a:rPr sz="1600" b="0" i="0">
                 <a:solidFill>
-                  <a:srgbClr val="FFFFFF"/>
+                  <a:srgbClr val="141413"/>
                 </a:solidFill>
                 <a:latin typeface="Consolas"/>
               </a:rPr>
@@ -9278,7 +9278,7 @@
             <a:r>
               <a:rPr sz="1600" b="0" i="0">
                 <a:solidFill>
-                  <a:srgbClr val="FFFFFF"/>
+                  <a:srgbClr val="141413"/>
                 </a:solidFill>
                 <a:latin typeface="Consolas"/>
               </a:rPr>
@@ -9297,7 +9297,7 @@
             <a:r>
               <a:rPr sz="1600" b="0" i="0">
                 <a:solidFill>
-                  <a:srgbClr val="757575"/>
+                  <a:srgbClr val="87867F"/>
                 </a:solidFill>
                 <a:latin typeface="Consolas"/>
               </a:rPr>
@@ -9316,7 +9316,7 @@
             <a:r>
               <a:rPr sz="1600" b="0" i="0">
                 <a:solidFill>
-                  <a:srgbClr val="898989"/>
+                  <a:srgbClr val="5E5D59"/>
                 </a:solidFill>
                 <a:latin typeface="Consolas"/>
               </a:rPr>
@@ -9335,7 +9335,7 @@
             <a:r>
               <a:rPr sz="1600" b="0" i="0">
                 <a:solidFill>
-                  <a:srgbClr val="76B900"/>
+                  <a:srgbClr val="C96442"/>
                 </a:solidFill>
                 <a:latin typeface="Consolas"/>
               </a:rPr>
@@ -9358,7 +9358,7 @@
     <p:bg>
       <p:bgPr>
         <a:solidFill>
-          <a:srgbClr val="000000"/>
+          <a:srgbClr val="F5F4ED"/>
         </a:solidFill>
         <a:effectLst/>
       </p:bgPr>
@@ -9396,7 +9396,7 @@
             <a:r>
               <a:rPr sz="2000" b="0" i="0">
                 <a:solidFill>
-                  <a:srgbClr val="76B900"/>
+                  <a:srgbClr val="C96442"/>
                 </a:solidFill>
                 <a:latin typeface="Arial"/>
               </a:rPr>
@@ -9431,9 +9431,9 @@
             <a:r>
               <a:rPr sz="4000" b="1" i="0">
                 <a:solidFill>
-                  <a:srgbClr val="FFFFFF"/>
-                </a:solidFill>
-                <a:latin typeface="Arial"/>
+                  <a:srgbClr val="141413"/>
+                </a:solidFill>
+                <a:latin typeface="Georgia"/>
               </a:rPr>
               <a:t>開發循環</a:t>
             </a:r>
@@ -9454,7 +9454,7 @@
     <p:bg>
       <p:bgPr>
         <a:solidFill>
-          <a:srgbClr val="000000"/>
+          <a:srgbClr val="F5F4ED"/>
         </a:solidFill>
         <a:effectLst/>
       </p:bgPr>
@@ -9491,9 +9491,9 @@
             <a:r>
               <a:rPr sz="3200" b="1" i="0">
                 <a:solidFill>
-                  <a:srgbClr val="FFFFFF"/>
-                </a:solidFill>
-                <a:latin typeface="Arial"/>
+                  <a:srgbClr val="141413"/>
+                </a:solidFill>
+                <a:latin typeface="Georgia"/>
               </a:rPr>
               <a:t>開發循環全貌（依任務模式分流）</a:t>
             </a:r>
@@ -9515,7 +9515,7 @@
             <a:avLst/>
           </a:prstGeom>
           <a:solidFill>
-            <a:srgbClr val="76B900"/>
+            <a:srgbClr val="C96442"/>
           </a:solidFill>
           <a:ln>
             <a:noFill/>
@@ -9577,7 +9577,7 @@
             <a:r>
               <a:rPr sz="2000" b="0" i="0">
                 <a:solidFill>
-                  <a:srgbClr val="FFFFFF"/>
+                  <a:srgbClr val="141413"/>
                 </a:solidFill>
                 <a:latin typeface="Arial"/>
               </a:rPr>
@@ -9596,7 +9596,7 @@
             <a:r>
               <a:rPr sz="800" b="0" i="0">
                 <a:solidFill>
-                  <a:srgbClr val="FFFFFF"/>
+                  <a:srgbClr val="141413"/>
                 </a:solidFill>
                 <a:latin typeface="Arial"/>
               </a:rPr>
@@ -9615,7 +9615,7 @@
             <a:r>
               <a:rPr sz="2000" b="0" i="0">
                 <a:solidFill>
-                  <a:srgbClr val="76B900"/>
+                  <a:srgbClr val="6B7A3F"/>
                 </a:solidFill>
                 <a:latin typeface="Arial"/>
               </a:rPr>
@@ -9634,7 +9634,7 @@
             <a:r>
               <a:rPr sz="1500" b="0" i="0">
                 <a:solidFill>
-                  <a:srgbClr val="898989"/>
+                  <a:srgbClr val="5E5D59"/>
                 </a:solidFill>
                 <a:latin typeface="Arial"/>
               </a:rPr>
@@ -9653,7 +9653,7 @@
             <a:r>
               <a:rPr sz="600" b="0" i="0">
                 <a:solidFill>
-                  <a:srgbClr val="FFFFFF"/>
+                  <a:srgbClr val="141413"/>
                 </a:solidFill>
                 <a:latin typeface="Arial"/>
               </a:rPr>
@@ -9672,7 +9672,7 @@
             <a:r>
               <a:rPr sz="2000" b="0" i="0">
                 <a:solidFill>
-                  <a:srgbClr val="FFFFFF"/>
+                  <a:srgbClr val="141413"/>
                 </a:solidFill>
                 <a:latin typeface="Arial"/>
               </a:rPr>
@@ -9691,7 +9691,7 @@
             <a:r>
               <a:rPr sz="1800" b="0" i="0">
                 <a:solidFill>
-                  <a:srgbClr val="FFFFFF"/>
+                  <a:srgbClr val="141413"/>
                 </a:solidFill>
                 <a:latin typeface="Arial"/>
               </a:rPr>
@@ -9710,7 +9710,7 @@
             <a:r>
               <a:rPr sz="1500" b="0" i="0">
                 <a:solidFill>
-                  <a:srgbClr val="898989"/>
+                  <a:srgbClr val="5E5D59"/>
                 </a:solidFill>
                 <a:latin typeface="Arial"/>
               </a:rPr>
@@ -9729,7 +9729,7 @@
             <a:r>
               <a:rPr sz="600" b="0" i="0">
                 <a:solidFill>
-                  <a:srgbClr val="FFFFFF"/>
+                  <a:srgbClr val="141413"/>
                 </a:solidFill>
                 <a:latin typeface="Arial"/>
               </a:rPr>
@@ -9748,7 +9748,7 @@
             <a:r>
               <a:rPr sz="2000" b="0" i="0">
                 <a:solidFill>
-                  <a:srgbClr val="EF9100"/>
+                  <a:srgbClr val="D97757"/>
                 </a:solidFill>
                 <a:latin typeface="Arial"/>
               </a:rPr>
@@ -9767,7 +9767,7 @@
             <a:r>
               <a:rPr sz="1800" b="0" i="0">
                 <a:solidFill>
-                  <a:srgbClr val="EF9100"/>
+                  <a:srgbClr val="D97757"/>
                 </a:solidFill>
                 <a:latin typeface="Arial"/>
               </a:rPr>
@@ -9786,7 +9786,7 @@
             <a:r>
               <a:rPr sz="1500" b="0" i="0">
                 <a:solidFill>
-                  <a:srgbClr val="898989"/>
+                  <a:srgbClr val="5E5D59"/>
                 </a:solidFill>
                 <a:latin typeface="Arial"/>
               </a:rPr>
@@ -9805,7 +9805,7 @@
             <a:r>
               <a:rPr sz="600" b="0" i="0">
                 <a:solidFill>
-                  <a:srgbClr val="FFFFFF"/>
+                  <a:srgbClr val="141413"/>
                 </a:solidFill>
                 <a:latin typeface="Arial"/>
               </a:rPr>
@@ -9824,7 +9824,7 @@
             <a:r>
               <a:rPr sz="1600" b="1" i="0">
                 <a:solidFill>
-                  <a:srgbClr val="76B900"/>
+                  <a:srgbClr val="C96442"/>
                 </a:solidFill>
                 <a:latin typeface="Arial"/>
               </a:rPr>
@@ -9847,7 +9847,7 @@
     <p:bg>
       <p:bgPr>
         <a:solidFill>
-          <a:srgbClr val="000000"/>
+          <a:srgbClr val="F5F4ED"/>
         </a:solidFill>
         <a:effectLst/>
       </p:bgPr>
@@ -9885,7 +9885,7 @@
             <a:r>
               <a:rPr sz="2000" b="0" i="0">
                 <a:solidFill>
-                  <a:srgbClr val="76B900"/>
+                  <a:srgbClr val="C96442"/>
                 </a:solidFill>
                 <a:latin typeface="Arial"/>
               </a:rPr>
@@ -9920,9 +9920,9 @@
             <a:r>
               <a:rPr sz="4000" b="1" i="0">
                 <a:solidFill>
-                  <a:srgbClr val="FFFFFF"/>
-                </a:solidFill>
-                <a:latin typeface="Arial"/>
+                  <a:srgbClr val="141413"/>
+                </a:solidFill>
+                <a:latin typeface="Georgia"/>
               </a:rPr>
               <a:t>後端 API — FastAPI + pytest</a:t>
             </a:r>
@@ -9943,7 +9943,7 @@
     <p:bg>
       <p:bgPr>
         <a:solidFill>
-          <a:srgbClr val="000000"/>
+          <a:srgbClr val="F5F4ED"/>
         </a:solidFill>
         <a:effectLst/>
       </p:bgPr>
@@ -9980,9 +9980,9 @@
             <a:r>
               <a:rPr sz="3000" b="1" i="0">
                 <a:solidFill>
-                  <a:srgbClr val="FFFFFF"/>
-                </a:solidFill>
-                <a:latin typeface="Arial"/>
+                  <a:srgbClr val="141413"/>
+                </a:solidFill>
+                <a:latin typeface="Georgia"/>
               </a:rPr>
               <a:t>/plan — AI 先想清楚再動手</a:t>
             </a:r>
@@ -10004,11 +10004,11 @@
             <a:avLst/>
           </a:prstGeom>
           <a:solidFill>
-            <a:srgbClr val="1A1A1A"/>
+            <a:srgbClr val="FAF9F5"/>
           </a:solidFill>
           <a:ln w="12700">
             <a:solidFill>
-              <a:srgbClr val="1A1A1A"/>
+              <a:srgbClr val="E8E6DC"/>
             </a:solidFill>
           </a:ln>
           <a:effectLst/>
@@ -10068,7 +10068,7 @@
             <a:r>
               <a:rPr sz="1600" b="0" i="0">
                 <a:solidFill>
-                  <a:srgbClr val="76B900"/>
+                  <a:srgbClr val="C96442"/>
                 </a:solidFill>
                 <a:latin typeface="Consolas"/>
               </a:rPr>
@@ -10087,7 +10087,7 @@
             <a:r>
               <a:rPr sz="1600" b="0" i="0">
                 <a:solidFill>
-                  <a:srgbClr val="757575"/>
+                  <a:srgbClr val="87867F"/>
                 </a:solidFill>
                 <a:latin typeface="Consolas"/>
               </a:rPr>
@@ -10106,7 +10106,7 @@
             <a:r>
               <a:rPr sz="1600" b="0" i="0">
                 <a:solidFill>
-                  <a:srgbClr val="FFFFFF"/>
+                  <a:srgbClr val="141413"/>
                 </a:solidFill>
                 <a:latin typeface="Consolas"/>
               </a:rPr>
@@ -10125,7 +10125,7 @@
             <a:r>
               <a:rPr sz="1600" b="0" i="0">
                 <a:solidFill>
-                  <a:srgbClr val="A7A7A7"/>
+                  <a:srgbClr val="3D3D3A"/>
                 </a:solidFill>
                 <a:latin typeface="Consolas"/>
               </a:rPr>
@@ -10144,7 +10144,7 @@
             <a:r>
               <a:rPr sz="1600" b="0" i="0">
                 <a:solidFill>
-                  <a:srgbClr val="A7A7A7"/>
+                  <a:srgbClr val="3D3D3A"/>
                 </a:solidFill>
                 <a:latin typeface="Consolas"/>
               </a:rPr>
@@ -10163,7 +10163,7 @@
             <a:r>
               <a:rPr sz="1600" b="0" i="0">
                 <a:solidFill>
-                  <a:srgbClr val="A7A7A7"/>
+                  <a:srgbClr val="3D3D3A"/>
                 </a:solidFill>
                 <a:latin typeface="Consolas"/>
               </a:rPr>
@@ -10182,7 +10182,7 @@
             <a:r>
               <a:rPr sz="1600" b="0" i="0">
                 <a:solidFill>
-                  <a:srgbClr val="A7A7A7"/>
+                  <a:srgbClr val="3D3D3A"/>
                 </a:solidFill>
                 <a:latin typeface="Consolas"/>
               </a:rPr>
@@ -10201,7 +10201,7 @@
             <a:r>
               <a:rPr sz="1600" b="0" i="0">
                 <a:solidFill>
-                  <a:srgbClr val="757575"/>
+                  <a:srgbClr val="87867F"/>
                 </a:solidFill>
                 <a:latin typeface="Consolas"/>
               </a:rPr>
@@ -10220,7 +10220,7 @@
             <a:r>
               <a:rPr sz="1600" b="0" i="0">
                 <a:solidFill>
-                  <a:srgbClr val="FFFFFF"/>
+                  <a:srgbClr val="141413"/>
                 </a:solidFill>
                 <a:latin typeface="Consolas"/>
               </a:rPr>
@@ -10239,7 +10239,7 @@
             <a:r>
               <a:rPr sz="1600" b="0" i="0">
                 <a:solidFill>
-                  <a:srgbClr val="A7A7A7"/>
+                  <a:srgbClr val="3D3D3A"/>
                 </a:solidFill>
                 <a:latin typeface="Consolas"/>
               </a:rPr>
@@ -10258,7 +10258,7 @@
             <a:r>
               <a:rPr sz="1600" b="0" i="0">
                 <a:solidFill>
-                  <a:srgbClr val="757575"/>
+                  <a:srgbClr val="87867F"/>
                 </a:solidFill>
                 <a:latin typeface="Consolas"/>
               </a:rPr>
@@ -10277,7 +10277,7 @@
             <a:r>
               <a:rPr sz="1600" b="0" i="0">
                 <a:solidFill>
-                  <a:srgbClr val="FFFFFF"/>
+                  <a:srgbClr val="141413"/>
                 </a:solidFill>
                 <a:latin typeface="Consolas"/>
               </a:rPr>
@@ -10296,7 +10296,7 @@
             <a:r>
               <a:rPr sz="1600" b="0" i="0">
                 <a:solidFill>
-                  <a:srgbClr val="A7A7A7"/>
+                  <a:srgbClr val="3D3D3A"/>
                 </a:solidFill>
                 <a:latin typeface="Consolas"/>
               </a:rPr>
@@ -10315,7 +10315,7 @@
             <a:r>
               <a:rPr sz="1600" b="0" i="0">
                 <a:solidFill>
-                  <a:srgbClr val="757575"/>
+                  <a:srgbClr val="87867F"/>
                 </a:solidFill>
                 <a:latin typeface="Consolas"/>
               </a:rPr>
@@ -10334,7 +10334,7 @@
             <a:r>
               <a:rPr sz="1600" b="0" i="0">
                 <a:solidFill>
-                  <a:srgbClr val="76B900"/>
+                  <a:srgbClr val="6B7A3F"/>
                 </a:solidFill>
                 <a:latin typeface="Consolas"/>
               </a:rPr>
@@ -10357,7 +10357,7 @@
     <p:bg>
       <p:bgPr>
         <a:solidFill>
-          <a:srgbClr val="000000"/>
+          <a:srgbClr val="F5F4ED"/>
         </a:solidFill>
         <a:effectLst/>
       </p:bgPr>
@@ -10394,9 +10394,9 @@
             <a:r>
               <a:rPr sz="3200" b="1" i="0">
                 <a:solidFill>
-                  <a:srgbClr val="FFFFFF"/>
-                </a:solidFill>
-                <a:latin typeface="Arial"/>
+                  <a:srgbClr val="141413"/>
+                </a:solidFill>
+                <a:latin typeface="Georgia"/>
               </a:rPr>
               <a:t>/tdd — 先寫測試，再寫實作</a:t>
             </a:r>
@@ -10418,7 +10418,7 @@
             <a:avLst/>
           </a:prstGeom>
           <a:solidFill>
-            <a:srgbClr val="76B900"/>
+            <a:srgbClr val="C96442"/>
           </a:solidFill>
           <a:ln>
             <a:noFill/>
@@ -10480,7 +10480,7 @@
             <a:r>
               <a:rPr sz="1800" b="0" i="0">
                 <a:solidFill>
-                  <a:srgbClr val="898989"/>
+                  <a:srgbClr val="5E5D59"/>
                 </a:solidFill>
                 <a:latin typeface="Arial"/>
               </a:rPr>
@@ -10499,7 +10499,7 @@
             <a:r>
               <a:rPr sz="800" b="0" i="0">
                 <a:solidFill>
-                  <a:srgbClr val="FFFFFF"/>
+                  <a:srgbClr val="141413"/>
                 </a:solidFill>
                 <a:latin typeface="Arial"/>
               </a:rPr>
@@ -10518,7 +10518,7 @@
             <a:r>
               <a:rPr sz="2400" b="1" i="0">
                 <a:solidFill>
-                  <a:srgbClr val="E52020"/>
+                  <a:srgbClr val="B53333"/>
                 </a:solidFill>
                 <a:latin typeface="Arial"/>
               </a:rPr>
@@ -10537,7 +10537,7 @@
             <a:r>
               <a:rPr sz="1600" b="0" i="0">
                 <a:solidFill>
-                  <a:srgbClr val="898989"/>
+                  <a:srgbClr val="5E5D59"/>
                 </a:solidFill>
                 <a:latin typeface="Arial"/>
               </a:rPr>
@@ -10556,7 +10556,7 @@
             <a:r>
               <a:rPr sz="800" b="0" i="0">
                 <a:solidFill>
-                  <a:srgbClr val="FFFFFF"/>
+                  <a:srgbClr val="141413"/>
                 </a:solidFill>
                 <a:latin typeface="Arial"/>
               </a:rPr>
@@ -10575,7 +10575,7 @@
             <a:r>
               <a:rPr sz="2400" b="1" i="0">
                 <a:solidFill>
-                  <a:srgbClr val="76B900"/>
+                  <a:srgbClr val="6B7A3F"/>
                 </a:solidFill>
                 <a:latin typeface="Arial"/>
               </a:rPr>
@@ -10594,7 +10594,7 @@
             <a:r>
               <a:rPr sz="1600" b="0" i="0">
                 <a:solidFill>
-                  <a:srgbClr val="898989"/>
+                  <a:srgbClr val="5E5D59"/>
                 </a:solidFill>
                 <a:latin typeface="Arial"/>
               </a:rPr>
@@ -10613,7 +10613,7 @@
             <a:r>
               <a:rPr sz="800" b="0" i="0">
                 <a:solidFill>
-                  <a:srgbClr val="FFFFFF"/>
+                  <a:srgbClr val="141413"/>
                 </a:solidFill>
                 <a:latin typeface="Arial"/>
               </a:rPr>
@@ -10632,7 +10632,7 @@
             <a:r>
               <a:rPr sz="2400" b="1" i="0">
                 <a:solidFill>
-                  <a:srgbClr val="76B900"/>
+                  <a:srgbClr val="C96442"/>
                 </a:solidFill>
                 <a:latin typeface="Arial"/>
               </a:rPr>
@@ -10651,7 +10651,7 @@
             <a:r>
               <a:rPr sz="1600" b="0" i="0">
                 <a:solidFill>
-                  <a:srgbClr val="898989"/>
+                  <a:srgbClr val="5E5D59"/>
                 </a:solidFill>
                 <a:latin typeface="Arial"/>
               </a:rPr>
@@ -10674,7 +10674,7 @@
     <p:bg>
       <p:bgPr>
         <a:solidFill>
-          <a:srgbClr val="000000"/>
+          <a:srgbClr val="F5F4ED"/>
         </a:solidFill>
         <a:effectLst/>
       </p:bgPr>
@@ -10711,9 +10711,9 @@
             <a:r>
               <a:rPr sz="3200" b="1" i="0">
                 <a:solidFill>
-                  <a:srgbClr val="FFFFFF"/>
-                </a:solidFill>
-                <a:latin typeface="Arial"/>
+                  <a:srgbClr val="141413"/>
+                </a:solidFill>
+                <a:latin typeface="Georgia"/>
               </a:rPr>
               <a:t>FastAPI /docs — 免費的互動文檔</a:t>
             </a:r>
@@ -10735,7 +10735,7 @@
             <a:avLst/>
           </a:prstGeom>
           <a:solidFill>
-            <a:srgbClr val="76B900"/>
+            <a:srgbClr val="C96442"/>
           </a:solidFill>
           <a:ln>
             <a:noFill/>
@@ -10797,7 +10797,7 @@
             <a:r>
               <a:rPr sz="2400" b="1" i="0">
                 <a:solidFill>
-                  <a:srgbClr val="76B900"/>
+                  <a:srgbClr val="C96442"/>
                 </a:solidFill>
                 <a:latin typeface="Arial"/>
               </a:rPr>
@@ -10816,7 +10816,7 @@
             <a:r>
               <a:rPr sz="800" b="0" i="0">
                 <a:solidFill>
-                  <a:srgbClr val="FFFFFF"/>
+                  <a:srgbClr val="141413"/>
                 </a:solidFill>
                 <a:latin typeface="Arial"/>
               </a:rPr>
@@ -10835,7 +10835,7 @@
             <a:r>
               <a:rPr sz="2000" b="0" i="0">
                 <a:solidFill>
-                  <a:srgbClr val="FFFFFF"/>
+                  <a:srgbClr val="141413"/>
                 </a:solidFill>
                 <a:latin typeface="Arial"/>
               </a:rPr>
@@ -10854,7 +10854,7 @@
             <a:r>
               <a:rPr sz="2000" b="0" i="0">
                 <a:solidFill>
-                  <a:srgbClr val="76B900"/>
+                  <a:srgbClr val="6B7A3F"/>
                 </a:solidFill>
                 <a:latin typeface="Arial"/>
               </a:rPr>
@@ -10873,7 +10873,7 @@
             <a:r>
               <a:rPr sz="1200" b="0" i="0">
                 <a:solidFill>
-                  <a:srgbClr val="FFFFFF"/>
+                  <a:srgbClr val="141413"/>
                 </a:solidFill>
                 <a:latin typeface="Arial"/>
               </a:rPr>
@@ -10892,7 +10892,7 @@
             <a:r>
               <a:rPr sz="2000" b="0" i="0">
                 <a:solidFill>
-                  <a:srgbClr val="FFFFFF"/>
+                  <a:srgbClr val="141413"/>
                 </a:solidFill>
                 <a:latin typeface="Arial"/>
               </a:rPr>
@@ -10911,7 +10911,7 @@
             <a:r>
               <a:rPr sz="2000" b="0" i="0">
                 <a:solidFill>
-                  <a:srgbClr val="FFFFFF"/>
+                  <a:srgbClr val="141413"/>
                 </a:solidFill>
                 <a:latin typeface="Arial"/>
               </a:rPr>
@@ -10930,7 +10930,7 @@
             <a:r>
               <a:rPr sz="2000" b="0" i="0">
                 <a:solidFill>
-                  <a:srgbClr val="FFFFFF"/>
+                  <a:srgbClr val="141413"/>
                 </a:solidFill>
                 <a:latin typeface="Arial"/>
               </a:rPr>
@@ -10949,7 +10949,7 @@
             <a:r>
               <a:rPr sz="1200" b="0" i="0">
                 <a:solidFill>
-                  <a:srgbClr val="FFFFFF"/>
+                  <a:srgbClr val="141413"/>
                 </a:solidFill>
                 <a:latin typeface="Arial"/>
               </a:rPr>
@@ -10968,7 +10968,7 @@
             <a:r>
               <a:rPr sz="1800" b="0" i="0">
                 <a:solidFill>
-                  <a:srgbClr val="898989"/>
+                  <a:srgbClr val="5E5D59"/>
                 </a:solidFill>
                 <a:latin typeface="Arial"/>
               </a:rPr>
@@ -10991,7 +10991,7 @@
     <p:bg>
       <p:bgPr>
         <a:solidFill>
-          <a:srgbClr val="000000"/>
+          <a:srgbClr val="F5F4ED"/>
         </a:solidFill>
         <a:effectLst/>
       </p:bgPr>
@@ -11028,9 +11028,9 @@
             <a:r>
               <a:rPr sz="3200" b="1" i="0">
                 <a:solidFill>
-                  <a:srgbClr val="FFFFFF"/>
-                </a:solidFill>
-                <a:latin typeface="Arial"/>
+                  <a:srgbClr val="141413"/>
+                </a:solidFill>
+                <a:latin typeface="Georgia"/>
               </a:rPr>
               <a:t>用 AI 寫程式的 5 個痛點</a:t>
             </a:r>
@@ -11052,7 +11052,7 @@
             <a:avLst/>
           </a:prstGeom>
           <a:solidFill>
-            <a:srgbClr val="76B900"/>
+            <a:srgbClr val="C96442"/>
           </a:solidFill>
           <a:ln>
             <a:noFill/>
@@ -11114,7 +11114,7 @@
             <a:r>
               <a:rPr sz="2200" b="0" i="0">
                 <a:solidFill>
-                  <a:srgbClr val="E52020"/>
+                  <a:srgbClr val="B53333"/>
                 </a:solidFill>
                 <a:latin typeface="Arial"/>
               </a:rPr>
@@ -11133,7 +11133,7 @@
             <a:r>
               <a:rPr sz="2200" b="0" i="0">
                 <a:solidFill>
-                  <a:srgbClr val="E52020"/>
+                  <a:srgbClr val="B53333"/>
                 </a:solidFill>
                 <a:latin typeface="Arial"/>
               </a:rPr>
@@ -11152,7 +11152,7 @@
             <a:r>
               <a:rPr sz="2200" b="0" i="0">
                 <a:solidFill>
-                  <a:srgbClr val="E52020"/>
+                  <a:srgbClr val="B53333"/>
                 </a:solidFill>
                 <a:latin typeface="Arial"/>
               </a:rPr>
@@ -11171,7 +11171,7 @@
             <a:r>
               <a:rPr sz="2200" b="0" i="0">
                 <a:solidFill>
-                  <a:srgbClr val="E52020"/>
+                  <a:srgbClr val="B53333"/>
                 </a:solidFill>
                 <a:latin typeface="Arial"/>
               </a:rPr>
@@ -11190,7 +11190,7 @@
             <a:r>
               <a:rPr sz="2200" b="0" i="0">
                 <a:solidFill>
-                  <a:srgbClr val="E52020"/>
+                  <a:srgbClr val="B53333"/>
                 </a:solidFill>
                 <a:latin typeface="Arial"/>
               </a:rPr>
@@ -11209,7 +11209,7 @@
             <a:r>
               <a:rPr sz="1200" b="0" i="0">
                 <a:solidFill>
-                  <a:srgbClr val="FFFFFF"/>
+                  <a:srgbClr val="141413"/>
                 </a:solidFill>
                 <a:latin typeface="Arial"/>
               </a:rPr>
@@ -11228,7 +11228,7 @@
             <a:r>
               <a:rPr sz="1800" b="0" i="0">
                 <a:solidFill>
-                  <a:srgbClr val="898989"/>
+                  <a:srgbClr val="5E5D59"/>
                 </a:solidFill>
                 <a:latin typeface="Arial"/>
               </a:rPr>
@@ -11251,7 +11251,7 @@
     <p:bg>
       <p:bgPr>
         <a:solidFill>
-          <a:srgbClr val="000000"/>
+          <a:srgbClr val="F5F4ED"/>
         </a:solidFill>
         <a:effectLst/>
       </p:bgPr>
@@ -11288,9 +11288,9 @@
             <a:r>
               <a:rPr sz="3000" b="1" i="0">
                 <a:solidFill>
-                  <a:srgbClr val="FFFFFF"/>
-                </a:solidFill>
-                <a:latin typeface="Arial"/>
+                  <a:srgbClr val="141413"/>
+                </a:solidFill>
+                <a:latin typeface="Georgia"/>
               </a:rPr>
               <a:t>/review-code — AI 審查程式碼</a:t>
             </a:r>
@@ -11312,11 +11312,11 @@
             <a:avLst/>
           </a:prstGeom>
           <a:solidFill>
-            <a:srgbClr val="1A1A1A"/>
+            <a:srgbClr val="FAF9F5"/>
           </a:solidFill>
           <a:ln w="12700">
             <a:solidFill>
-              <a:srgbClr val="1A1A1A"/>
+              <a:srgbClr val="E8E6DC"/>
             </a:solidFill>
           </a:ln>
           <a:effectLst/>
@@ -11376,7 +11376,7 @@
             <a:r>
               <a:rPr sz="1600" b="0" i="0">
                 <a:solidFill>
-                  <a:srgbClr val="76B900"/>
+                  <a:srgbClr val="C96442"/>
                 </a:solidFill>
                 <a:latin typeface="Consolas"/>
               </a:rPr>
@@ -11395,7 +11395,7 @@
             <a:r>
               <a:rPr sz="1600" b="0" i="0">
                 <a:solidFill>
-                  <a:srgbClr val="757575"/>
+                  <a:srgbClr val="87867F"/>
                 </a:solidFill>
                 <a:latin typeface="Consolas"/>
               </a:rPr>
@@ -11414,7 +11414,7 @@
             <a:r>
               <a:rPr sz="1600" b="0" i="0">
                 <a:solidFill>
-                  <a:srgbClr val="76B900"/>
+                  <a:srgbClr val="6B7A3F"/>
                 </a:solidFill>
                 <a:latin typeface="Consolas"/>
               </a:rPr>
@@ -11433,7 +11433,7 @@
             <a:r>
               <a:rPr sz="1600" b="0" i="0">
                 <a:solidFill>
-                  <a:srgbClr val="76B900"/>
+                  <a:srgbClr val="6B7A3F"/>
                 </a:solidFill>
                 <a:latin typeface="Consolas"/>
               </a:rPr>
@@ -11452,7 +11452,7 @@
             <a:r>
               <a:rPr sz="1600" b="0" i="0">
                 <a:solidFill>
-                  <a:srgbClr val="76B900"/>
+                  <a:srgbClr val="6B7A3F"/>
                 </a:solidFill>
                 <a:latin typeface="Consolas"/>
               </a:rPr>
@@ -11471,7 +11471,7 @@
             <a:r>
               <a:rPr sz="1600" b="0" i="0">
                 <a:solidFill>
-                  <a:srgbClr val="EF9100"/>
+                  <a:srgbClr val="D97757"/>
                 </a:solidFill>
                 <a:latin typeface="Consolas"/>
               </a:rPr>
@@ -11490,7 +11490,7 @@
             <a:r>
               <a:rPr sz="1600" b="0" i="0">
                 <a:solidFill>
-                  <a:srgbClr val="76B900"/>
+                  <a:srgbClr val="6B7A3F"/>
                 </a:solidFill>
                 <a:latin typeface="Consolas"/>
               </a:rPr>
@@ -11509,7 +11509,7 @@
             <a:r>
               <a:rPr sz="1600" b="0" i="0">
                 <a:solidFill>
-                  <a:srgbClr val="76B900"/>
+                  <a:srgbClr val="6B7A3F"/>
                 </a:solidFill>
                 <a:latin typeface="Consolas"/>
               </a:rPr>
@@ -11528,7 +11528,7 @@
             <a:r>
               <a:rPr sz="1600" b="0" i="0">
                 <a:solidFill>
-                  <a:srgbClr val="757575"/>
+                  <a:srgbClr val="87867F"/>
                 </a:solidFill>
                 <a:latin typeface="Consolas"/>
               </a:rPr>
@@ -11547,7 +11547,7 @@
             <a:r>
               <a:rPr sz="1600" b="0" i="0">
                 <a:solidFill>
-                  <a:srgbClr val="FFFFFF"/>
+                  <a:srgbClr val="141413"/>
                 </a:solidFill>
                 <a:latin typeface="Consolas"/>
               </a:rPr>
@@ -11566,7 +11566,7 @@
             <a:r>
               <a:rPr sz="1600" b="0" i="0">
                 <a:solidFill>
-                  <a:srgbClr val="EF9100"/>
+                  <a:srgbClr val="D97757"/>
                 </a:solidFill>
                 <a:latin typeface="Consolas"/>
               </a:rPr>
@@ -11589,7 +11589,7 @@
     <p:bg>
       <p:bgPr>
         <a:solidFill>
-          <a:srgbClr val="000000"/>
+          <a:srgbClr val="F5F4ED"/>
         </a:solidFill>
         <a:effectLst/>
       </p:bgPr>
@@ -11627,7 +11627,7 @@
             <a:r>
               <a:rPr sz="2000" b="0" i="0">
                 <a:solidFill>
-                  <a:srgbClr val="76B900"/>
+                  <a:srgbClr val="C96442"/>
                 </a:solidFill>
                 <a:latin typeface="Arial"/>
               </a:rPr>
@@ -11662,9 +11662,9 @@
             <a:r>
               <a:rPr sz="4000" b="1" i="0">
                 <a:solidFill>
-                  <a:srgbClr val="FFFFFF"/>
-                </a:solidFill>
-                <a:latin typeface="Arial"/>
+                  <a:srgbClr val="141413"/>
+                </a:solidFill>
+                <a:latin typeface="Georgia"/>
               </a:rPr>
               <a:t>前端 UI — React + Tailwind</a:t>
             </a:r>
@@ -11685,7 +11685,7 @@
     <p:bg>
       <p:bgPr>
         <a:solidFill>
-          <a:srgbClr val="000000"/>
+          <a:srgbClr val="F5F4ED"/>
         </a:solidFill>
         <a:effectLst/>
       </p:bgPr>
@@ -11722,9 +11722,9 @@
             <a:r>
               <a:rPr sz="3200" b="1" i="0">
                 <a:solidFill>
-                  <a:srgbClr val="FFFFFF"/>
-                </a:solidFill>
-                <a:latin typeface="Arial"/>
+                  <a:srgbClr val="141413"/>
+                </a:solidFill>
+                <a:latin typeface="Georgia"/>
               </a:rPr>
               <a:t>第 2 輪：同樣的流程，加快節奏</a:t>
             </a:r>
@@ -11746,7 +11746,7 @@
             <a:avLst/>
           </a:prstGeom>
           <a:solidFill>
-            <a:srgbClr val="76B900"/>
+            <a:srgbClr val="C96442"/>
           </a:solidFill>
           <a:ln>
             <a:noFill/>
@@ -11808,7 +11808,7 @@
             <a:r>
               <a:rPr sz="2200" b="0" i="0">
                 <a:solidFill>
-                  <a:srgbClr val="FFFFFF"/>
+                  <a:srgbClr val="141413"/>
                 </a:solidFill>
                 <a:latin typeface="Arial"/>
               </a:rPr>
@@ -11827,7 +11827,7 @@
             <a:r>
               <a:rPr sz="2200" b="0" i="0">
                 <a:solidFill>
-                  <a:srgbClr val="FFFFFF"/>
+                  <a:srgbClr val="141413"/>
                 </a:solidFill>
                 <a:latin typeface="Arial"/>
               </a:rPr>
@@ -11846,7 +11846,7 @@
             <a:r>
               <a:rPr sz="800" b="0" i="0">
                 <a:solidFill>
-                  <a:srgbClr val="FFFFFF"/>
+                  <a:srgbClr val="141413"/>
                 </a:solidFill>
                 <a:latin typeface="Arial"/>
               </a:rPr>
@@ -11865,7 +11865,7 @@
             <a:r>
               <a:rPr sz="2200" b="1" i="0">
                 <a:solidFill>
-                  <a:srgbClr val="76B900"/>
+                  <a:srgbClr val="C96442"/>
                 </a:solidFill>
                 <a:latin typeface="Arial"/>
               </a:rPr>
@@ -11884,7 +11884,7 @@
             <a:r>
               <a:rPr sz="400" b="0" i="0">
                 <a:solidFill>
-                  <a:srgbClr val="FFFFFF"/>
+                  <a:srgbClr val="141413"/>
                 </a:solidFill>
                 <a:latin typeface="Arial"/>
               </a:rPr>
@@ -11903,7 +11903,7 @@
             <a:r>
               <a:rPr sz="2000" b="0" i="0">
                 <a:solidFill>
-                  <a:srgbClr val="FFFFFF"/>
+                  <a:srgbClr val="141413"/>
                 </a:solidFill>
                 <a:latin typeface="Arial"/>
               </a:rPr>
@@ -11922,7 +11922,7 @@
             <a:r>
               <a:rPr sz="1600" b="0" i="0">
                 <a:solidFill>
-                  <a:srgbClr val="898989"/>
+                  <a:srgbClr val="5E5D59"/>
                 </a:solidFill>
                 <a:latin typeface="Arial"/>
               </a:rPr>
@@ -11941,7 +11941,7 @@
             <a:r>
               <a:rPr sz="400" b="0" i="0">
                 <a:solidFill>
-                  <a:srgbClr val="FFFFFF"/>
+                  <a:srgbClr val="141413"/>
                 </a:solidFill>
                 <a:latin typeface="Arial"/>
               </a:rPr>
@@ -11960,7 +11960,7 @@
             <a:r>
               <a:rPr sz="2000" b="0" i="0">
                 <a:solidFill>
-                  <a:srgbClr val="FFFFFF"/>
+                  <a:srgbClr val="141413"/>
                 </a:solidFill>
                 <a:latin typeface="Arial"/>
               </a:rPr>
@@ -11979,7 +11979,7 @@
             <a:r>
               <a:rPr sz="1600" b="0" i="0">
                 <a:solidFill>
-                  <a:srgbClr val="898989"/>
+                  <a:srgbClr val="5E5D59"/>
                 </a:solidFill>
                 <a:latin typeface="Arial"/>
               </a:rPr>
@@ -11998,7 +11998,7 @@
             <a:r>
               <a:rPr sz="800" b="0" i="0">
                 <a:solidFill>
-                  <a:srgbClr val="FFFFFF"/>
+                  <a:srgbClr val="141413"/>
                 </a:solidFill>
                 <a:latin typeface="Arial"/>
               </a:rPr>
@@ -12017,7 +12017,7 @@
             <a:r>
               <a:rPr sz="2000" b="0" i="0">
                 <a:solidFill>
-                  <a:srgbClr val="76B900"/>
+                  <a:srgbClr val="6B7A3F"/>
                 </a:solidFill>
                 <a:latin typeface="Arial"/>
               </a:rPr>
@@ -12040,7 +12040,7 @@
     <p:bg>
       <p:bgPr>
         <a:solidFill>
-          <a:srgbClr val="000000"/>
+          <a:srgbClr val="F5F4ED"/>
         </a:solidFill>
         <a:effectLst/>
       </p:bgPr>
@@ -12078,7 +12078,7 @@
             <a:r>
               <a:rPr sz="2000" b="0" i="0">
                 <a:solidFill>
-                  <a:srgbClr val="76B900"/>
+                  <a:srgbClr val="C96442"/>
                 </a:solidFill>
                 <a:latin typeface="Arial"/>
               </a:rPr>
@@ -12113,9 +12113,9 @@
             <a:r>
               <a:rPr sz="4000" b="1" i="0">
                 <a:solidFill>
-                  <a:srgbClr val="FFFFFF"/>
-                </a:solidFill>
-                <a:latin typeface="Arial"/>
+                  <a:srgbClr val="141413"/>
+                </a:solidFill>
+                <a:latin typeface="Georgia"/>
               </a:rPr>
               <a:t>修 Bug — /build-fix</a:t>
             </a:r>
@@ -12136,7 +12136,7 @@
     <p:bg>
       <p:bgPr>
         <a:solidFill>
-          <a:srgbClr val="000000"/>
+          <a:srgbClr val="F5F4ED"/>
         </a:solidFill>
         <a:effectLst/>
       </p:bgPr>
@@ -12173,9 +12173,9 @@
             <a:r>
               <a:rPr sz="3200" b="1" i="0">
                 <a:solidFill>
-                  <a:srgbClr val="FFFFFF"/>
-                </a:solidFill>
-                <a:latin typeface="Arial"/>
+                  <a:srgbClr val="141413"/>
+                </a:solidFill>
+                <a:latin typeface="Georgia"/>
               </a:rPr>
               <a:t>/build-fix — 出錯不可怕</a:t>
             </a:r>
@@ -12197,7 +12197,7 @@
             <a:avLst/>
           </a:prstGeom>
           <a:solidFill>
-            <a:srgbClr val="76B900"/>
+            <a:srgbClr val="C96442"/>
           </a:solidFill>
           <a:ln>
             <a:noFill/>
@@ -12259,7 +12259,7 @@
             <a:r>
               <a:rPr sz="2200" b="0" i="0">
                 <a:solidFill>
-                  <a:srgbClr val="FFFFFF"/>
+                  <a:srgbClr val="141413"/>
                 </a:solidFill>
                 <a:latin typeface="Arial"/>
               </a:rPr>
@@ -12278,7 +12278,7 @@
             <a:r>
               <a:rPr sz="800" b="0" i="0">
                 <a:solidFill>
-                  <a:srgbClr val="FFFFFF"/>
+                  <a:srgbClr val="141413"/>
                 </a:solidFill>
                 <a:latin typeface="Arial"/>
               </a:rPr>
@@ -12297,7 +12297,7 @@
             <a:r>
               <a:rPr sz="2200" b="1" i="0">
                 <a:solidFill>
-                  <a:srgbClr val="76B900"/>
+                  <a:srgbClr val="C96442"/>
                 </a:solidFill>
                 <a:latin typeface="Arial"/>
               </a:rPr>
@@ -12316,7 +12316,7 @@
             <a:r>
               <a:rPr sz="800" b="0" i="0">
                 <a:solidFill>
-                  <a:srgbClr val="FFFFFF"/>
+                  <a:srgbClr val="141413"/>
                 </a:solidFill>
                 <a:latin typeface="Arial"/>
               </a:rPr>
@@ -12335,7 +12335,7 @@
             <a:r>
               <a:rPr sz="2000" b="0" i="0">
                 <a:solidFill>
-                  <a:srgbClr val="FFFFFF"/>
+                  <a:srgbClr val="141413"/>
                 </a:solidFill>
                 <a:latin typeface="Arial"/>
               </a:rPr>
@@ -12354,7 +12354,7 @@
             <a:r>
               <a:rPr sz="2000" b="0" i="0">
                 <a:solidFill>
-                  <a:srgbClr val="FFFFFF"/>
+                  <a:srgbClr val="141413"/>
                 </a:solidFill>
                 <a:latin typeface="Arial"/>
               </a:rPr>
@@ -12373,7 +12373,7 @@
             <a:r>
               <a:rPr sz="2000" b="0" i="0">
                 <a:solidFill>
-                  <a:srgbClr val="FFFFFF"/>
+                  <a:srgbClr val="141413"/>
                 </a:solidFill>
                 <a:latin typeface="Arial"/>
               </a:rPr>
@@ -12392,7 +12392,7 @@
             <a:r>
               <a:rPr sz="2000" b="0" i="0">
                 <a:solidFill>
-                  <a:srgbClr val="FFFFFF"/>
+                  <a:srgbClr val="141413"/>
                 </a:solidFill>
                 <a:latin typeface="Arial"/>
               </a:rPr>
@@ -12411,7 +12411,7 @@
             <a:r>
               <a:rPr sz="1200" b="0" i="0">
                 <a:solidFill>
-                  <a:srgbClr val="FFFFFF"/>
+                  <a:srgbClr val="141413"/>
                 </a:solidFill>
                 <a:latin typeface="Arial"/>
               </a:rPr>
@@ -12430,7 +12430,7 @@
             <a:r>
               <a:rPr sz="2000" b="0" i="0">
                 <a:solidFill>
-                  <a:srgbClr val="76B900"/>
+                  <a:srgbClr val="6B7A3F"/>
                 </a:solidFill>
                 <a:latin typeface="Arial"/>
               </a:rPr>
@@ -12449,7 +12449,7 @@
             <a:r>
               <a:rPr sz="800" b="0" i="0">
                 <a:solidFill>
-                  <a:srgbClr val="FFFFFF"/>
+                  <a:srgbClr val="141413"/>
                 </a:solidFill>
                 <a:latin typeface="Arial"/>
               </a:rPr>
@@ -12468,7 +12468,7 @@
             <a:r>
               <a:rPr sz="1800" b="0" i="0">
                 <a:solidFill>
-                  <a:srgbClr val="898989"/>
+                  <a:srgbClr val="5E5D59"/>
                 </a:solidFill>
                 <a:latin typeface="Arial"/>
               </a:rPr>
@@ -12491,7 +12491,7 @@
     <p:bg>
       <p:bgPr>
         <a:solidFill>
-          <a:srgbClr val="000000"/>
+          <a:srgbClr val="F5F4ED"/>
         </a:solidFill>
         <a:effectLst/>
       </p:bgPr>
@@ -12528,9 +12528,9 @@
             <a:r>
               <a:rPr sz="3200" b="1" i="0">
                 <a:solidFill>
-                  <a:srgbClr val="FFFFFF"/>
-                </a:solidFill>
-                <a:latin typeface="Arial"/>
+                  <a:srgbClr val="141413"/>
+                </a:solidFill>
+                <a:latin typeface="Georgia"/>
               </a:rPr>
               <a:t>Chapter 3 小結 — 3 種 Lane 完成</a:t>
             </a:r>
@@ -12552,7 +12552,7 @@
             <a:avLst/>
           </a:prstGeom>
           <a:solidFill>
-            <a:srgbClr val="76B900"/>
+            <a:srgbClr val="C96442"/>
           </a:solidFill>
           <a:ln>
             <a:noFill/>
@@ -12614,7 +12614,7 @@
             <a:r>
               <a:rPr sz="2200" b="0" i="0">
                 <a:solidFill>
-                  <a:srgbClr val="FFFFFF"/>
+                  <a:srgbClr val="141413"/>
                 </a:solidFill>
                 <a:latin typeface="Arial"/>
               </a:rPr>
@@ -12633,7 +12633,7 @@
             <a:r>
               <a:rPr sz="2200" b="0" i="0">
                 <a:solidFill>
-                  <a:srgbClr val="FFFFFF"/>
+                  <a:srgbClr val="141413"/>
                 </a:solidFill>
                 <a:latin typeface="Arial"/>
               </a:rPr>
@@ -12652,7 +12652,7 @@
             <a:r>
               <a:rPr sz="2200" b="0" i="0">
                 <a:solidFill>
-                  <a:srgbClr val="FFFFFF"/>
+                  <a:srgbClr val="141413"/>
                 </a:solidFill>
                 <a:latin typeface="Arial"/>
               </a:rPr>
@@ -12671,7 +12671,7 @@
             <a:r>
               <a:rPr sz="1200" b="0" i="0">
                 <a:solidFill>
-                  <a:srgbClr val="FFFFFF"/>
+                  <a:srgbClr val="141413"/>
                 </a:solidFill>
                 <a:latin typeface="Arial"/>
               </a:rPr>
@@ -12690,7 +12690,7 @@
             <a:r>
               <a:rPr sz="2000" b="1" i="0">
                 <a:solidFill>
-                  <a:srgbClr val="76B900"/>
+                  <a:srgbClr val="C96442"/>
                 </a:solidFill>
                 <a:latin typeface="Arial"/>
               </a:rPr>
@@ -12709,7 +12709,7 @@
             <a:r>
               <a:rPr sz="2000" b="0" i="0">
                 <a:solidFill>
-                  <a:srgbClr val="76B900"/>
+                  <a:srgbClr val="6B7A3F"/>
                 </a:solidFill>
                 <a:latin typeface="Arial"/>
               </a:rPr>
@@ -12728,7 +12728,7 @@
             <a:r>
               <a:rPr sz="2000" b="0" i="0">
                 <a:solidFill>
-                  <a:srgbClr val="FFFFFF"/>
+                  <a:srgbClr val="141413"/>
                 </a:solidFill>
                 <a:latin typeface="Arial"/>
               </a:rPr>
@@ -12747,7 +12747,7 @@
             <a:r>
               <a:rPr sz="2000" b="0" i="0">
                 <a:solidFill>
-                  <a:srgbClr val="EF9100"/>
+                  <a:srgbClr val="D97757"/>
                 </a:solidFill>
                 <a:latin typeface="Arial"/>
               </a:rPr>
@@ -12766,7 +12766,7 @@
             <a:r>
               <a:rPr sz="1200" b="0" i="0">
                 <a:solidFill>
-                  <a:srgbClr val="FFFFFF"/>
+                  <a:srgbClr val="141413"/>
                 </a:solidFill>
                 <a:latin typeface="Arial"/>
               </a:rPr>
@@ -12785,7 +12785,7 @@
             <a:r>
               <a:rPr sz="1800" b="1" i="0">
                 <a:solidFill>
-                  <a:srgbClr val="76B900"/>
+                  <a:srgbClr val="6B7A3F"/>
                 </a:solidFill>
                 <a:latin typeface="Arial"/>
               </a:rPr>
@@ -12804,7 +12804,7 @@
             <a:r>
               <a:rPr sz="1500" b="0" i="0">
                 <a:solidFill>
-                  <a:srgbClr val="A7A7A7"/>
+                  <a:srgbClr val="3D3D3A"/>
                 </a:solidFill>
                 <a:latin typeface="Arial"/>
               </a:rPr>
@@ -12827,7 +12827,7 @@
     <p:bg>
       <p:bgPr>
         <a:solidFill>
-          <a:srgbClr val="000000"/>
+          <a:srgbClr val="F5F4ED"/>
         </a:solidFill>
         <a:effectLst/>
       </p:bgPr>
@@ -12865,7 +12865,7 @@
             <a:r>
               <a:rPr sz="2000" b="0" i="0">
                 <a:solidFill>
-                  <a:srgbClr val="76B900"/>
+                  <a:srgbClr val="C96442"/>
                 </a:solidFill>
                 <a:latin typeface="Arial"/>
               </a:rPr>
@@ -12900,9 +12900,9 @@
             <a:r>
               <a:rPr sz="4000" b="1" i="0">
                 <a:solidFill>
-                  <a:srgbClr val="FFFFFF"/>
-                </a:solidFill>
-                <a:latin typeface="Arial"/>
+                  <a:srgbClr val="141413"/>
+                </a:solidFill>
+                <a:latin typeface="Georgia"/>
               </a:rPr>
               <a:t>品質驗證</a:t>
             </a:r>
@@ -12923,7 +12923,7 @@
     <p:bg>
       <p:bgPr>
         <a:solidFill>
-          <a:srgbClr val="000000"/>
+          <a:srgbClr val="F5F4ED"/>
         </a:solidFill>
         <a:effectLst/>
       </p:bgPr>
@@ -12960,9 +12960,9 @@
             <a:r>
               <a:rPr sz="3000" b="1" i="0">
                 <a:solidFill>
-                  <a:srgbClr val="FFFFFF"/>
-                </a:solidFill>
-                <a:latin typeface="Arial"/>
+                  <a:srgbClr val="141413"/>
+                </a:solidFill>
+                <a:latin typeface="Georgia"/>
               </a:rPr>
               <a:t>/verify — 三道品質門（依模式自動）</a:t>
             </a:r>
@@ -12984,11 +12984,11 @@
             <a:avLst/>
           </a:prstGeom>
           <a:solidFill>
-            <a:srgbClr val="1A1A1A"/>
+            <a:srgbClr val="FAF9F5"/>
           </a:solidFill>
           <a:ln w="12700">
             <a:solidFill>
-              <a:srgbClr val="1A1A1A"/>
+              <a:srgbClr val="E8E6DC"/>
             </a:solidFill>
           </a:ln>
           <a:effectLst/>
@@ -13048,7 +13048,7 @@
             <a:r>
               <a:rPr sz="1600" b="0" i="0">
                 <a:solidFill>
-                  <a:srgbClr val="76B900"/>
+                  <a:srgbClr val="C96442"/>
                 </a:solidFill>
                 <a:latin typeface="Consolas"/>
               </a:rPr>
@@ -13067,7 +13067,7 @@
             <a:r>
               <a:rPr sz="1600" b="0" i="0">
                 <a:solidFill>
-                  <a:srgbClr val="757575"/>
+                  <a:srgbClr val="87867F"/>
                 </a:solidFill>
                 <a:latin typeface="Consolas"/>
               </a:rPr>
@@ -13086,7 +13086,7 @@
             <a:r>
               <a:rPr sz="1600" b="0" i="0">
                 <a:solidFill>
-                  <a:srgbClr val="FFFFFF"/>
+                  <a:srgbClr val="141413"/>
                 </a:solidFill>
                 <a:latin typeface="Consolas"/>
               </a:rPr>
@@ -13105,7 +13105,7 @@
             <a:r>
               <a:rPr sz="1600" b="0" i="0">
                 <a:solidFill>
-                  <a:srgbClr val="76B900"/>
+                  <a:srgbClr val="6B7A3F"/>
                 </a:solidFill>
                 <a:latin typeface="Consolas"/>
               </a:rPr>
@@ -13124,7 +13124,7 @@
             <a:r>
               <a:rPr sz="1600" b="0" i="0">
                 <a:solidFill>
-                  <a:srgbClr val="76B900"/>
+                  <a:srgbClr val="6B7A3F"/>
                 </a:solidFill>
                 <a:latin typeface="Consolas"/>
               </a:rPr>
@@ -13143,7 +13143,7 @@
             <a:r>
               <a:rPr sz="1600" b="0" i="0">
                 <a:solidFill>
-                  <a:srgbClr val="757575"/>
+                  <a:srgbClr val="87867F"/>
                 </a:solidFill>
                 <a:latin typeface="Consolas"/>
               </a:rPr>
@@ -13162,7 +13162,7 @@
             <a:r>
               <a:rPr sz="1600" b="0" i="0">
                 <a:solidFill>
-                  <a:srgbClr val="FFFFFF"/>
+                  <a:srgbClr val="141413"/>
                 </a:solidFill>
                 <a:latin typeface="Consolas"/>
               </a:rPr>
@@ -13181,7 +13181,7 @@
             <a:r>
               <a:rPr sz="1600" b="0" i="0">
                 <a:solidFill>
-                  <a:srgbClr val="76B900"/>
+                  <a:srgbClr val="6B7A3F"/>
                 </a:solidFill>
                 <a:latin typeface="Consolas"/>
               </a:rPr>
@@ -13200,7 +13200,7 @@
             <a:r>
               <a:rPr sz="1600" b="0" i="0">
                 <a:solidFill>
-                  <a:srgbClr val="76B900"/>
+                  <a:srgbClr val="6B7A3F"/>
                 </a:solidFill>
                 <a:latin typeface="Consolas"/>
               </a:rPr>
@@ -13219,7 +13219,7 @@
             <a:r>
               <a:rPr sz="1600" b="0" i="0">
                 <a:solidFill>
-                  <a:srgbClr val="76B900"/>
+                  <a:srgbClr val="6B7A3F"/>
                 </a:solidFill>
                 <a:latin typeface="Consolas"/>
               </a:rPr>
@@ -13238,7 +13238,7 @@
             <a:r>
               <a:rPr sz="1600" b="0" i="0">
                 <a:solidFill>
-                  <a:srgbClr val="757575"/>
+                  <a:srgbClr val="87867F"/>
                 </a:solidFill>
                 <a:latin typeface="Consolas"/>
               </a:rPr>
@@ -13257,7 +13257,7 @@
             <a:r>
               <a:rPr sz="1600" b="0" i="0">
                 <a:solidFill>
-                  <a:srgbClr val="FFFFFF"/>
+                  <a:srgbClr val="141413"/>
                 </a:solidFill>
                 <a:latin typeface="Consolas"/>
               </a:rPr>
@@ -13276,7 +13276,7 @@
             <a:r>
               <a:rPr sz="1600" b="0" i="0">
                 <a:solidFill>
-                  <a:srgbClr val="76B900"/>
+                  <a:srgbClr val="6B7A3F"/>
                 </a:solidFill>
                 <a:latin typeface="Consolas"/>
               </a:rPr>
@@ -13295,7 +13295,7 @@
             <a:r>
               <a:rPr sz="1600" b="0" i="0">
                 <a:solidFill>
-                  <a:srgbClr val="76B900"/>
+                  <a:srgbClr val="6B7A3F"/>
                 </a:solidFill>
                 <a:latin typeface="Consolas"/>
               </a:rPr>
@@ -13314,7 +13314,7 @@
             <a:r>
               <a:rPr sz="1600" b="0" i="0">
                 <a:solidFill>
-                  <a:srgbClr val="757575"/>
+                  <a:srgbClr val="87867F"/>
                 </a:solidFill>
                 <a:latin typeface="Consolas"/>
               </a:rPr>
@@ -13333,7 +13333,7 @@
             <a:r>
               <a:rPr sz="1600" b="0" i="0">
                 <a:solidFill>
-                  <a:srgbClr val="76B900"/>
+                  <a:srgbClr val="6B7A3F"/>
                 </a:solidFill>
                 <a:latin typeface="Consolas"/>
               </a:rPr>
@@ -13356,7 +13356,7 @@
     <p:bg>
       <p:bgPr>
         <a:solidFill>
-          <a:srgbClr val="000000"/>
+          <a:srgbClr val="F5F4ED"/>
         </a:solidFill>
         <a:effectLst/>
       </p:bgPr>
@@ -13393,9 +13393,9 @@
             <a:r>
               <a:rPr sz="3200" b="1" i="0">
                 <a:solidFill>
-                  <a:srgbClr val="FFFFFF"/>
-                </a:solidFill>
-                <a:latin typeface="Arial"/>
+                  <a:srgbClr val="141413"/>
+                </a:solidFill>
+                <a:latin typeface="Georgia"/>
               </a:rPr>
               <a:t>/e2e — Playwright 自動操作瀏覽器</a:t>
             </a:r>
@@ -13417,7 +13417,7 @@
             <a:avLst/>
           </a:prstGeom>
           <a:solidFill>
-            <a:srgbClr val="76B900"/>
+            <a:srgbClr val="C96442"/>
           </a:solidFill>
           <a:ln>
             <a:noFill/>
@@ -13479,7 +13479,7 @@
             <a:r>
               <a:rPr sz="1800" b="0" i="0">
                 <a:solidFill>
-                  <a:srgbClr val="898989"/>
+                  <a:srgbClr val="5E5D59"/>
                 </a:solidFill>
                 <a:latin typeface="Arial"/>
               </a:rPr>
@@ -13498,7 +13498,7 @@
             <a:r>
               <a:rPr sz="800" b="0" i="0">
                 <a:solidFill>
-                  <a:srgbClr val="FFFFFF"/>
+                  <a:srgbClr val="141413"/>
                 </a:solidFill>
                 <a:latin typeface="Arial"/>
               </a:rPr>
@@ -13517,7 +13517,7 @@
             <a:r>
               <a:rPr sz="2000" b="0" i="0">
                 <a:solidFill>
-                  <a:srgbClr val="FFFFFF"/>
+                  <a:srgbClr val="141413"/>
                 </a:solidFill>
                 <a:latin typeface="Arial"/>
               </a:rPr>
@@ -13536,7 +13536,7 @@
             <a:r>
               <a:rPr sz="2000" b="0" i="0">
                 <a:solidFill>
-                  <a:srgbClr val="FFFFFF"/>
+                  <a:srgbClr val="141413"/>
                 </a:solidFill>
                 <a:latin typeface="Arial"/>
               </a:rPr>
@@ -13555,7 +13555,7 @@
             <a:r>
               <a:rPr sz="400" b="0" i="0">
                 <a:solidFill>
-                  <a:srgbClr val="FFFFFF"/>
+                  <a:srgbClr val="141413"/>
                 </a:solidFill>
                 <a:latin typeface="Arial"/>
               </a:rPr>
@@ -13574,7 +13574,7 @@
             <a:r>
               <a:rPr sz="1800" b="0" i="0">
                 <a:solidFill>
-                  <a:srgbClr val="A7A7A7"/>
+                  <a:srgbClr val="3D3D3A"/>
                 </a:solidFill>
                 <a:latin typeface="Arial"/>
               </a:rPr>
@@ -13593,7 +13593,7 @@
             <a:r>
               <a:rPr sz="1800" b="0" i="0">
                 <a:solidFill>
-                  <a:srgbClr val="A7A7A7"/>
+                  <a:srgbClr val="3D3D3A"/>
                 </a:solidFill>
                 <a:latin typeface="Arial"/>
               </a:rPr>
@@ -13612,7 +13612,7 @@
             <a:r>
               <a:rPr sz="1800" b="0" i="0">
                 <a:solidFill>
-                  <a:srgbClr val="A7A7A7"/>
+                  <a:srgbClr val="3D3D3A"/>
                 </a:solidFill>
                 <a:latin typeface="Arial"/>
               </a:rPr>
@@ -13631,7 +13631,7 @@
             <a:r>
               <a:rPr sz="1800" b="0" i="0">
                 <a:solidFill>
-                  <a:srgbClr val="A7A7A7"/>
+                  <a:srgbClr val="3D3D3A"/>
                 </a:solidFill>
                 <a:latin typeface="Arial"/>
               </a:rPr>
@@ -13650,7 +13650,7 @@
             <a:r>
               <a:rPr sz="1800" b="0" i="0">
                 <a:solidFill>
-                  <a:srgbClr val="A7A7A7"/>
+                  <a:srgbClr val="3D3D3A"/>
                 </a:solidFill>
                 <a:latin typeface="Arial"/>
               </a:rPr>
@@ -13669,7 +13669,7 @@
             <a:r>
               <a:rPr sz="800" b="0" i="0">
                 <a:solidFill>
-                  <a:srgbClr val="FFFFFF"/>
+                  <a:srgbClr val="141413"/>
                 </a:solidFill>
                 <a:latin typeface="Arial"/>
               </a:rPr>
@@ -13688,7 +13688,7 @@
             <a:r>
               <a:rPr sz="2000" b="0" i="0">
                 <a:solidFill>
-                  <a:srgbClr val="76B900"/>
+                  <a:srgbClr val="6B7A3F"/>
                 </a:solidFill>
                 <a:latin typeface="Arial"/>
               </a:rPr>
@@ -13711,7 +13711,7 @@
     <p:bg>
       <p:bgPr>
         <a:solidFill>
-          <a:srgbClr val="000000"/>
+          <a:srgbClr val="F5F4ED"/>
         </a:solidFill>
         <a:effectLst/>
       </p:bgPr>
@@ -13748,9 +13748,9 @@
             <a:r>
               <a:rPr sz="3200" b="1" i="0">
                 <a:solidFill>
-                  <a:srgbClr val="FFFFFF"/>
-                </a:solidFill>
-                <a:latin typeface="Arial"/>
+                  <a:srgbClr val="141413"/>
+                </a:solidFill>
+                <a:latin typeface="Georgia"/>
               </a:rPr>
               <a:t>/time-log — 自動時間追蹤</a:t>
             </a:r>
@@ -13772,7 +13772,7 @@
             <a:avLst/>
           </a:prstGeom>
           <a:solidFill>
-            <a:srgbClr val="76B900"/>
+            <a:srgbClr val="C96442"/>
           </a:solidFill>
           <a:ln>
             <a:noFill/>
@@ -13834,7 +13834,7 @@
             <a:r>
               <a:rPr sz="2400" b="1" i="0">
                 <a:solidFill>
-                  <a:srgbClr val="76B900"/>
+                  <a:srgbClr val="C96442"/>
                 </a:solidFill>
                 <a:latin typeface="Arial"/>
               </a:rPr>
@@ -13853,7 +13853,7 @@
             <a:r>
               <a:rPr sz="1200" b="0" i="0">
                 <a:solidFill>
-                  <a:srgbClr val="FFFFFF"/>
+                  <a:srgbClr val="141413"/>
                 </a:solidFill>
                 <a:latin typeface="Arial"/>
               </a:rPr>
@@ -13872,7 +13872,7 @@
             <a:r>
               <a:rPr sz="2200" b="0" i="0">
                 <a:solidFill>
-                  <a:srgbClr val="FFFFFF"/>
+                  <a:srgbClr val="141413"/>
                 </a:solidFill>
                 <a:latin typeface="Arial"/>
               </a:rPr>
@@ -13891,7 +13891,7 @@
             <a:r>
               <a:rPr sz="2200" b="0" i="0">
                 <a:solidFill>
-                  <a:srgbClr val="FFFFFF"/>
+                  <a:srgbClr val="141413"/>
                 </a:solidFill>
                 <a:latin typeface="Arial"/>
               </a:rPr>
@@ -13910,7 +13910,7 @@
             <a:r>
               <a:rPr sz="2200" b="0" i="0">
                 <a:solidFill>
-                  <a:srgbClr val="FFFFFF"/>
+                  <a:srgbClr val="141413"/>
                 </a:solidFill>
                 <a:latin typeface="Arial"/>
               </a:rPr>
@@ -13929,7 +13929,7 @@
             <a:r>
               <a:rPr sz="2200" b="0" i="0">
                 <a:solidFill>
-                  <a:srgbClr val="FFFFFF"/>
+                  <a:srgbClr val="141413"/>
                 </a:solidFill>
                 <a:latin typeface="Arial"/>
               </a:rPr>
@@ -13948,7 +13948,7 @@
             <a:r>
               <a:rPr sz="2200" b="0" i="0">
                 <a:solidFill>
-                  <a:srgbClr val="FFFFFF"/>
+                  <a:srgbClr val="141413"/>
                 </a:solidFill>
                 <a:latin typeface="Arial"/>
               </a:rPr>
@@ -13967,7 +13967,7 @@
             <a:r>
               <a:rPr sz="2200" b="0" i="0">
                 <a:solidFill>
-                  <a:srgbClr val="757575"/>
+                  <a:srgbClr val="87867F"/>
                 </a:solidFill>
                 <a:latin typeface="Arial"/>
               </a:rPr>
@@ -13986,7 +13986,7 @@
             <a:r>
               <a:rPr sz="2200" b="1" i="0">
                 <a:solidFill>
-                  <a:srgbClr val="76B900"/>
+                  <a:srgbClr val="6B7A3F"/>
                 </a:solidFill>
                 <a:latin typeface="Arial"/>
               </a:rPr>
@@ -14005,7 +14005,7 @@
             <a:r>
               <a:rPr sz="1200" b="0" i="0">
                 <a:solidFill>
-                  <a:srgbClr val="FFFFFF"/>
+                  <a:srgbClr val="141413"/>
                 </a:solidFill>
                 <a:latin typeface="Arial"/>
               </a:rPr>
@@ -14024,7 +14024,7 @@
             <a:r>
               <a:rPr sz="1800" b="0" i="0">
                 <a:solidFill>
-                  <a:srgbClr val="898989"/>
+                  <a:srgbClr val="5E5D59"/>
                 </a:solidFill>
                 <a:latin typeface="Arial"/>
               </a:rPr>
@@ -14047,7 +14047,7 @@
     <p:bg>
       <p:bgPr>
         <a:solidFill>
-          <a:srgbClr val="000000"/>
+          <a:srgbClr val="F5F4ED"/>
         </a:solidFill>
         <a:effectLst/>
       </p:bgPr>
@@ -14084,9 +14084,9 @@
             <a:r>
               <a:rPr sz="3200" b="1" i="0">
                 <a:solidFill>
-                  <a:srgbClr val="FFFFFF"/>
-                </a:solidFill>
-                <a:latin typeface="Arial"/>
+                  <a:srgbClr val="141413"/>
+                </a:solidFill>
+                <a:latin typeface="Georgia"/>
               </a:rPr>
               <a:t>VibeCoding 模板 = AI 開發的標準作業程序</a:t>
             </a:r>
@@ -14108,7 +14108,7 @@
             <a:avLst/>
           </a:prstGeom>
           <a:solidFill>
-            <a:srgbClr val="76B900"/>
+            <a:srgbClr val="C96442"/>
           </a:solidFill>
           <a:ln>
             <a:noFill/>
@@ -14170,7 +14170,7 @@
             <a:r>
               <a:rPr sz="2000" b="0" i="0">
                 <a:solidFill>
-                  <a:srgbClr val="FFFFFF"/>
+                  <a:srgbClr val="141413"/>
                 </a:solidFill>
                 <a:latin typeface="Arial"/>
               </a:rPr>
@@ -14189,7 +14189,7 @@
             <a:r>
               <a:rPr sz="2000" b="0" i="0">
                 <a:solidFill>
-                  <a:srgbClr val="FFFFFF"/>
+                  <a:srgbClr val="141413"/>
                 </a:solidFill>
                 <a:latin typeface="Arial"/>
               </a:rPr>
@@ -14208,7 +14208,7 @@
             <a:r>
               <a:rPr sz="2000" b="0" i="0">
                 <a:solidFill>
-                  <a:srgbClr val="FFFFFF"/>
+                  <a:srgbClr val="141413"/>
                 </a:solidFill>
                 <a:latin typeface="Arial"/>
               </a:rPr>
@@ -14227,7 +14227,7 @@
             <a:r>
               <a:rPr sz="2000" b="0" i="0">
                 <a:solidFill>
-                  <a:srgbClr val="FFFFFF"/>
+                  <a:srgbClr val="141413"/>
                 </a:solidFill>
                 <a:latin typeface="Arial"/>
               </a:rPr>
@@ -14246,7 +14246,7 @@
             <a:r>
               <a:rPr sz="2000" b="0" i="0">
                 <a:solidFill>
-                  <a:srgbClr val="FFFFFF"/>
+                  <a:srgbClr val="141413"/>
                 </a:solidFill>
                 <a:latin typeface="Arial"/>
               </a:rPr>
@@ -14265,7 +14265,7 @@
             <a:r>
               <a:rPr sz="2000" b="0" i="0">
                 <a:solidFill>
-                  <a:srgbClr val="FFFFFF"/>
+                  <a:srgbClr val="141413"/>
                 </a:solidFill>
                 <a:latin typeface="Arial"/>
               </a:rPr>
@@ -14284,7 +14284,7 @@
             <a:r>
               <a:rPr sz="1200" b="0" i="0">
                 <a:solidFill>
-                  <a:srgbClr val="FFFFFF"/>
+                  <a:srgbClr val="141413"/>
                 </a:solidFill>
                 <a:latin typeface="Arial"/>
               </a:rPr>
@@ -14303,7 +14303,7 @@
             <a:r>
               <a:rPr sz="2000" b="1" i="0">
                 <a:solidFill>
-                  <a:srgbClr val="76B900"/>
+                  <a:srgbClr val="C96442"/>
                 </a:solidFill>
                 <a:latin typeface="Arial"/>
               </a:rPr>
@@ -14326,7 +14326,7 @@
     <p:bg>
       <p:bgPr>
         <a:solidFill>
-          <a:srgbClr val="000000"/>
+          <a:srgbClr val="F5F4ED"/>
         </a:solidFill>
         <a:effectLst/>
       </p:bgPr>
@@ -14364,7 +14364,7 @@
             <a:r>
               <a:rPr sz="2000" b="0" i="0">
                 <a:solidFill>
-                  <a:srgbClr val="76B900"/>
+                  <a:srgbClr val="C96442"/>
                 </a:solidFill>
                 <a:latin typeface="Arial"/>
               </a:rPr>
@@ -14399,9 +14399,9 @@
             <a:r>
               <a:rPr sz="4000" b="1" i="0">
                 <a:solidFill>
-                  <a:srgbClr val="FFFFFF"/>
-                </a:solidFill>
-                <a:latin typeface="Arial"/>
+                  <a:srgbClr val="141413"/>
+                </a:solidFill>
+                <a:latin typeface="Georgia"/>
               </a:rPr>
               <a:t>進階技巧與收尾</a:t>
             </a:r>
@@ -14422,7 +14422,7 @@
     <p:bg>
       <p:bgPr>
         <a:solidFill>
-          <a:srgbClr val="000000"/>
+          <a:srgbClr val="F5F4ED"/>
         </a:solidFill>
         <a:effectLst/>
       </p:bgPr>
@@ -14459,9 +14459,9 @@
             <a:r>
               <a:rPr sz="3200" b="1" i="0">
                 <a:solidFill>
-                  <a:srgbClr val="FFFFFF"/>
-                </a:solidFill>
-                <a:latin typeface="Arial"/>
+                  <a:srgbClr val="141413"/>
+                </a:solidFill>
+                <a:latin typeface="Georgia"/>
               </a:rPr>
               <a:t>更多可以探索的功能</a:t>
             </a:r>
@@ -14483,7 +14483,7 @@
             <a:avLst/>
           </a:prstGeom>
           <a:solidFill>
-            <a:srgbClr val="76B900"/>
+            <a:srgbClr val="C96442"/>
           </a:solidFill>
           <a:ln>
             <a:noFill/>
@@ -14545,7 +14545,7 @@
             <a:r>
               <a:rPr sz="2200" b="0" i="0">
                 <a:solidFill>
-                  <a:srgbClr val="FFFFFF"/>
+                  <a:srgbClr val="141413"/>
                 </a:solidFill>
                 <a:latin typeface="Arial"/>
               </a:rPr>
@@ -14564,7 +14564,7 @@
             <a:r>
               <a:rPr sz="1600" b="0" i="0">
                 <a:solidFill>
-                  <a:srgbClr val="898989"/>
+                  <a:srgbClr val="5E5D59"/>
                 </a:solidFill>
                 <a:latin typeface="Arial"/>
               </a:rPr>
@@ -14583,7 +14583,7 @@
             <a:r>
               <a:rPr sz="600" b="0" i="0">
                 <a:solidFill>
-                  <a:srgbClr val="FFFFFF"/>
+                  <a:srgbClr val="141413"/>
                 </a:solidFill>
                 <a:latin typeface="Arial"/>
               </a:rPr>
@@ -14602,7 +14602,7 @@
             <a:r>
               <a:rPr sz="2200" b="0" i="0">
                 <a:solidFill>
-                  <a:srgbClr val="FFFFFF"/>
+                  <a:srgbClr val="141413"/>
                 </a:solidFill>
                 <a:latin typeface="Arial"/>
               </a:rPr>
@@ -14621,7 +14621,7 @@
             <a:r>
               <a:rPr sz="1600" b="0" i="0">
                 <a:solidFill>
-                  <a:srgbClr val="898989"/>
+                  <a:srgbClr val="5E5D59"/>
                 </a:solidFill>
                 <a:latin typeface="Arial"/>
               </a:rPr>
@@ -14640,7 +14640,7 @@
             <a:r>
               <a:rPr sz="600" b="0" i="0">
                 <a:solidFill>
-                  <a:srgbClr val="FFFFFF"/>
+                  <a:srgbClr val="141413"/>
                 </a:solidFill>
                 <a:latin typeface="Arial"/>
               </a:rPr>
@@ -14659,7 +14659,7 @@
             <a:r>
               <a:rPr sz="2200" b="0" i="0">
                 <a:solidFill>
-                  <a:srgbClr val="FFFFFF"/>
+                  <a:srgbClr val="141413"/>
                 </a:solidFill>
                 <a:latin typeface="Arial"/>
               </a:rPr>
@@ -14678,7 +14678,7 @@
             <a:r>
               <a:rPr sz="1600" b="0" i="0">
                 <a:solidFill>
-                  <a:srgbClr val="898989"/>
+                  <a:srgbClr val="5E5D59"/>
                 </a:solidFill>
                 <a:latin typeface="Arial"/>
               </a:rPr>
@@ -14697,7 +14697,7 @@
             <a:r>
               <a:rPr sz="600" b="0" i="0">
                 <a:solidFill>
-                  <a:srgbClr val="FFFFFF"/>
+                  <a:srgbClr val="141413"/>
                 </a:solidFill>
                 <a:latin typeface="Arial"/>
               </a:rPr>
@@ -14716,7 +14716,7 @@
             <a:r>
               <a:rPr sz="2200" b="0" i="0">
                 <a:solidFill>
-                  <a:srgbClr val="FFFFFF"/>
+                  <a:srgbClr val="141413"/>
                 </a:solidFill>
                 <a:latin typeface="Arial"/>
               </a:rPr>
@@ -14735,7 +14735,7 @@
             <a:r>
               <a:rPr sz="1600" b="0" i="0">
                 <a:solidFill>
-                  <a:srgbClr val="898989"/>
+                  <a:srgbClr val="5E5D59"/>
                 </a:solidFill>
                 <a:latin typeface="Arial"/>
               </a:rPr>
@@ -14758,7 +14758,7 @@
     <p:bg>
       <p:bgPr>
         <a:solidFill>
-          <a:srgbClr val="000000"/>
+          <a:srgbClr val="F5F4ED"/>
         </a:solidFill>
         <a:effectLst/>
       </p:bgPr>
@@ -14795,9 +14795,9 @@
             <a:r>
               <a:rPr sz="3200" b="1" i="0">
                 <a:solidFill>
-                  <a:srgbClr val="FFFFFF"/>
-                </a:solidFill>
-                <a:latin typeface="Arial"/>
+                  <a:srgbClr val="141413"/>
+                </a:solidFill>
+                <a:latin typeface="Georgia"/>
               </a:rPr>
               <a:t>完整流程回顧</a:t>
             </a:r>
@@ -14819,7 +14819,7 @@
             <a:avLst/>
           </a:prstGeom>
           <a:solidFill>
-            <a:srgbClr val="76B900"/>
+            <a:srgbClr val="C96442"/>
           </a:solidFill>
           <a:ln>
             <a:noFill/>
@@ -14881,7 +14881,7 @@
             <a:r>
               <a:rPr sz="2000" b="0" i="0">
                 <a:solidFill>
-                  <a:srgbClr val="898989"/>
+                  <a:srgbClr val="5E5D59"/>
                 </a:solidFill>
                 <a:latin typeface="Arial"/>
               </a:rPr>
@@ -14900,7 +14900,7 @@
             <a:r>
               <a:rPr sz="2000" b="0" i="0">
                 <a:solidFill>
-                  <a:srgbClr val="898989"/>
+                  <a:srgbClr val="5E5D59"/>
                 </a:solidFill>
                 <a:latin typeface="Arial"/>
               </a:rPr>
@@ -14919,7 +14919,7 @@
             <a:r>
               <a:rPr sz="2000" b="0" i="0">
                 <a:solidFill>
-                  <a:srgbClr val="FFFFFF"/>
+                  <a:srgbClr val="141413"/>
                 </a:solidFill>
                 <a:latin typeface="Arial"/>
               </a:rPr>
@@ -14938,7 +14938,7 @@
             <a:r>
               <a:rPr sz="2000" b="0" i="0">
                 <a:solidFill>
-                  <a:srgbClr val="FFFFFF"/>
+                  <a:srgbClr val="141413"/>
                 </a:solidFill>
                 <a:latin typeface="Arial"/>
               </a:rPr>
@@ -14957,7 +14957,7 @@
             <a:r>
               <a:rPr sz="2000" b="0" i="0">
                 <a:solidFill>
-                  <a:srgbClr val="898989"/>
+                  <a:srgbClr val="5E5D59"/>
                 </a:solidFill>
                 <a:latin typeface="Arial"/>
               </a:rPr>
@@ -14976,7 +14976,7 @@
             <a:r>
               <a:rPr sz="1600" b="0" i="0">
                 <a:solidFill>
-                  <a:srgbClr val="FFFFFF"/>
+                  <a:srgbClr val="141413"/>
                 </a:solidFill>
                 <a:latin typeface="Arial"/>
               </a:rPr>
@@ -14995,7 +14995,7 @@
             <a:r>
               <a:rPr sz="2200" b="1" i="0">
                 <a:solidFill>
-                  <a:srgbClr val="76B900"/>
+                  <a:srgbClr val="6B7A3F"/>
                 </a:solidFill>
                 <a:latin typeface="Arial"/>
               </a:rPr>
@@ -15018,7 +15018,7 @@
     <p:bg>
       <p:bgPr>
         <a:solidFill>
-          <a:srgbClr val="000000"/>
+          <a:srgbClr val="F5F4ED"/>
         </a:solidFill>
         <a:effectLst/>
       </p:bgPr>
@@ -15055,9 +15055,9 @@
             <a:r>
               <a:rPr sz="3200" b="1" i="0">
                 <a:solidFill>
-                  <a:srgbClr val="FFFFFF"/>
-                </a:solidFill>
-                <a:latin typeface="Arial"/>
+                  <a:srgbClr val="141413"/>
+                </a:solidFill>
+                <a:latin typeface="Georgia"/>
               </a:rPr>
               <a:t>課後作業 — 選一個挑戰</a:t>
             </a:r>
@@ -15079,7 +15079,7 @@
             <a:avLst/>
           </a:prstGeom>
           <a:solidFill>
-            <a:srgbClr val="76B900"/>
+            <a:srgbClr val="C96442"/>
           </a:solidFill>
           <a:ln>
             <a:noFill/>
@@ -15141,7 +15141,7 @@
             <a:r>
               <a:rPr sz="2400" b="1" i="0">
                 <a:solidFill>
-                  <a:srgbClr val="76B900"/>
+                  <a:srgbClr val="6B7A3F"/>
                 </a:solidFill>
                 <a:latin typeface="Arial"/>
               </a:rPr>
@@ -15160,7 +15160,7 @@
             <a:r>
               <a:rPr sz="1800" b="0" i="0">
                 <a:solidFill>
-                  <a:srgbClr val="FFFFFF"/>
+                  <a:srgbClr val="141413"/>
                 </a:solidFill>
                 <a:latin typeface="Arial"/>
               </a:rPr>
@@ -15179,7 +15179,7 @@
             <a:r>
               <a:rPr sz="800" b="0" i="0">
                 <a:solidFill>
-                  <a:srgbClr val="FFFFFF"/>
+                  <a:srgbClr val="141413"/>
                 </a:solidFill>
                 <a:latin typeface="Arial"/>
               </a:rPr>
@@ -15198,7 +15198,7 @@
             <a:r>
               <a:rPr sz="2400" b="1" i="0">
                 <a:solidFill>
-                  <a:srgbClr val="76B900"/>
+                  <a:srgbClr val="C96442"/>
                 </a:solidFill>
                 <a:latin typeface="Arial"/>
               </a:rPr>
@@ -15217,7 +15217,7 @@
             <a:r>
               <a:rPr sz="1800" b="0" i="0">
                 <a:solidFill>
-                  <a:srgbClr val="FFFFFF"/>
+                  <a:srgbClr val="141413"/>
                 </a:solidFill>
                 <a:latin typeface="Arial"/>
               </a:rPr>
@@ -15236,7 +15236,7 @@
             <a:r>
               <a:rPr sz="800" b="0" i="0">
                 <a:solidFill>
-                  <a:srgbClr val="FFFFFF"/>
+                  <a:srgbClr val="141413"/>
                 </a:solidFill>
                 <a:latin typeface="Arial"/>
               </a:rPr>
@@ -15255,7 +15255,7 @@
             <a:r>
               <a:rPr sz="2400" b="1" i="0">
                 <a:solidFill>
-                  <a:srgbClr val="EF9100"/>
+                  <a:srgbClr val="D97757"/>
                 </a:solidFill>
                 <a:latin typeface="Arial"/>
               </a:rPr>
@@ -15274,7 +15274,7 @@
             <a:r>
               <a:rPr sz="1800" b="0" i="0">
                 <a:solidFill>
-                  <a:srgbClr val="FFFFFF"/>
+                  <a:srgbClr val="141413"/>
                 </a:solidFill>
                 <a:latin typeface="Arial"/>
               </a:rPr>
@@ -15297,7 +15297,7 @@
     <p:bg>
       <p:bgPr>
         <a:solidFill>
-          <a:srgbClr val="000000"/>
+          <a:srgbClr val="F5F4ED"/>
         </a:solidFill>
         <a:effectLst/>
       </p:bgPr>
@@ -15334,9 +15334,9 @@
             <a:r>
               <a:rPr sz="3200" b="1" i="0">
                 <a:solidFill>
-                  <a:srgbClr val="FFFFFF"/>
-                </a:solidFill>
-                <a:latin typeface="Arial"/>
+                  <a:srgbClr val="141413"/>
+                </a:solidFill>
+                <a:latin typeface="Georgia"/>
               </a:rPr>
               <a:t>推薦探索路徑</a:t>
             </a:r>
@@ -15358,7 +15358,7 @@
             <a:avLst/>
           </a:prstGeom>
           <a:solidFill>
-            <a:srgbClr val="76B900"/>
+            <a:srgbClr val="C96442"/>
           </a:solidFill>
           <a:ln>
             <a:noFill/>
@@ -15420,7 +15420,7 @@
             <a:r>
               <a:rPr sz="2000" b="0" i="0">
                 <a:solidFill>
-                  <a:srgbClr val="FFFFFF"/>
+                  <a:srgbClr val="141413"/>
                 </a:solidFill>
                 <a:latin typeface="Arial"/>
               </a:rPr>
@@ -15439,7 +15439,7 @@
             <a:r>
               <a:rPr sz="2000" b="0" i="0">
                 <a:solidFill>
-                  <a:srgbClr val="FFFFFF"/>
+                  <a:srgbClr val="141413"/>
                 </a:solidFill>
                 <a:latin typeface="Arial"/>
               </a:rPr>
@@ -15458,7 +15458,7 @@
             <a:r>
               <a:rPr sz="2000" b="0" i="0">
                 <a:solidFill>
-                  <a:srgbClr val="FFFFFF"/>
+                  <a:srgbClr val="141413"/>
                 </a:solidFill>
                 <a:latin typeface="Arial"/>
               </a:rPr>
@@ -15477,7 +15477,7 @@
             <a:r>
               <a:rPr sz="2000" b="0" i="0">
                 <a:solidFill>
-                  <a:srgbClr val="FFFFFF"/>
+                  <a:srgbClr val="141413"/>
                 </a:solidFill>
                 <a:latin typeface="Arial"/>
               </a:rPr>
@@ -15496,7 +15496,7 @@
             <a:r>
               <a:rPr sz="2000" b="0" i="0">
                 <a:solidFill>
-                  <a:srgbClr val="FFFFFF"/>
+                  <a:srgbClr val="141413"/>
                 </a:solidFill>
                 <a:latin typeface="Arial"/>
               </a:rPr>
@@ -15515,7 +15515,7 @@
             <a:r>
               <a:rPr sz="2000" b="0" i="0">
                 <a:solidFill>
-                  <a:srgbClr val="FFFFFF"/>
+                  <a:srgbClr val="141413"/>
                 </a:solidFill>
                 <a:latin typeface="Arial"/>
               </a:rPr>
@@ -15534,7 +15534,7 @@
             <a:r>
               <a:rPr sz="1600" b="0" i="0">
                 <a:solidFill>
-                  <a:srgbClr val="FFFFFF"/>
+                  <a:srgbClr val="141413"/>
                 </a:solidFill>
                 <a:latin typeface="Arial"/>
               </a:rPr>
@@ -15553,7 +15553,7 @@
             <a:r>
               <a:rPr sz="1800" b="0" i="0">
                 <a:solidFill>
-                  <a:srgbClr val="76B900"/>
+                  <a:srgbClr val="C96442"/>
                 </a:solidFill>
                 <a:latin typeface="Arial"/>
               </a:rPr>
@@ -15576,7 +15576,7 @@
     <p:bg>
       <p:bgPr>
         <a:solidFill>
-          <a:srgbClr val="000000"/>
+          <a:srgbClr val="F5F4ED"/>
         </a:solidFill>
         <a:effectLst/>
       </p:bgPr>
@@ -15614,9 +15614,9 @@
             <a:r>
               <a:rPr sz="4400" b="1" i="0">
                 <a:solidFill>
-                  <a:srgbClr val="FFFFFF"/>
-                </a:solidFill>
-                <a:latin typeface="Arial"/>
+                  <a:srgbClr val="141413"/>
+                </a:solidFill>
+                <a:latin typeface="Georgia"/>
               </a:rPr>
               <a:t>Q &amp; A</a:t>
             </a:r>
@@ -15633,7 +15633,7 @@
             <a:r>
               <a:rPr sz="2200" b="0" i="0">
                 <a:solidFill>
-                  <a:srgbClr val="898989"/>
+                  <a:srgbClr val="5E5D59"/>
                 </a:solidFill>
                 <a:latin typeface="Arial"/>
               </a:rPr>
@@ -15657,7 +15657,7 @@
             <a:avLst/>
           </a:prstGeom>
           <a:solidFill>
-            <a:srgbClr val="76B900"/>
+            <a:srgbClr val="C96442"/>
           </a:solidFill>
           <a:ln>
             <a:noFill/>
@@ -15699,7 +15699,7 @@
     <p:bg>
       <p:bgPr>
         <a:solidFill>
-          <a:srgbClr val="000000"/>
+          <a:srgbClr val="F5F4ED"/>
         </a:solidFill>
         <a:effectLst/>
       </p:bgPr>
@@ -15737,9 +15737,9 @@
             <a:r>
               <a:rPr sz="4400" b="1" i="0">
                 <a:solidFill>
-                  <a:srgbClr val="FFFFFF"/>
-                </a:solidFill>
-                <a:latin typeface="Arial"/>
+                  <a:srgbClr val="141413"/>
+                </a:solidFill>
+                <a:latin typeface="Georgia"/>
               </a:rPr>
               <a:t>Thank You</a:t>
             </a:r>
@@ -15756,7 +15756,7 @@
             <a:r>
               <a:rPr sz="2200" b="0" i="0">
                 <a:solidFill>
-                  <a:srgbClr val="898989"/>
+                  <a:srgbClr val="5E5D59"/>
                 </a:solidFill>
                 <a:latin typeface="Arial"/>
               </a:rPr>
@@ -15780,7 +15780,7 @@
             <a:avLst/>
           </a:prstGeom>
           <a:solidFill>
-            <a:srgbClr val="76B900"/>
+            <a:srgbClr val="C96442"/>
           </a:solidFill>
           <a:ln>
             <a:noFill/>
@@ -15822,7 +15822,7 @@
     <p:bg>
       <p:bgPr>
         <a:solidFill>
-          <a:srgbClr val="000000"/>
+          <a:srgbClr val="F5F4ED"/>
         </a:solidFill>
         <a:effectLst/>
       </p:bgPr>
@@ -15859,9 +15859,9 @@
             <a:r>
               <a:rPr sz="3200" b="1" i="0">
                 <a:solidFill>
-                  <a:srgbClr val="FFFFFF"/>
-                </a:solidFill>
-                <a:latin typeface="Arial"/>
+                  <a:srgbClr val="141413"/>
+                </a:solidFill>
+                <a:latin typeface="Georgia"/>
               </a:rPr>
               <a:t>對比 — 沒模板 vs 有模板</a:t>
             </a:r>
@@ -15883,7 +15883,7 @@
             <a:avLst/>
           </a:prstGeom>
           <a:solidFill>
-            <a:srgbClr val="76B900"/>
+            <a:srgbClr val="C96442"/>
           </a:solidFill>
           <a:ln>
             <a:noFill/>
@@ -15936,7 +15936,7 @@
             <a:r>
               <a:rPr sz="2200" b="1" i="0">
                 <a:solidFill>
-                  <a:srgbClr val="76B900"/>
+                  <a:srgbClr val="C96442"/>
                 </a:solidFill>
                 <a:latin typeface="Arial"/>
               </a:rPr>
@@ -15955,7 +15955,7 @@
             <a:r>
               <a:rPr sz="1800" b="0" i="0">
                 <a:solidFill>
-                  <a:srgbClr val="FFFFFF"/>
+                  <a:srgbClr val="141413"/>
                 </a:solidFill>
                 <a:latin typeface="Arial"/>
               </a:rPr>
@@ -15974,7 +15974,7 @@
             <a:r>
               <a:rPr sz="1800" b="0" i="0">
                 <a:solidFill>
-                  <a:srgbClr val="FFFFFF"/>
+                  <a:srgbClr val="141413"/>
                 </a:solidFill>
                 <a:latin typeface="Arial"/>
               </a:rPr>
@@ -15993,7 +15993,7 @@
             <a:r>
               <a:rPr sz="1800" b="0" i="0">
                 <a:solidFill>
-                  <a:srgbClr val="FFFFFF"/>
+                  <a:srgbClr val="141413"/>
                 </a:solidFill>
                 <a:latin typeface="Arial"/>
               </a:rPr>
@@ -16012,7 +16012,7 @@
             <a:r>
               <a:rPr sz="1800" b="0" i="0">
                 <a:solidFill>
-                  <a:srgbClr val="FFFFFF"/>
+                  <a:srgbClr val="141413"/>
                 </a:solidFill>
                 <a:latin typeface="Arial"/>
               </a:rPr>
@@ -16031,7 +16031,7 @@
             <a:r>
               <a:rPr sz="1800" b="0" i="0">
                 <a:solidFill>
-                  <a:srgbClr val="FFFFFF"/>
+                  <a:srgbClr val="141413"/>
                 </a:solidFill>
                 <a:latin typeface="Arial"/>
               </a:rPr>
@@ -16050,7 +16050,7 @@
             <a:r>
               <a:rPr sz="1800" b="0" i="0">
                 <a:solidFill>
-                  <a:srgbClr val="FFFFFF"/>
+                  <a:srgbClr val="141413"/>
                 </a:solidFill>
                 <a:latin typeface="Arial"/>
               </a:rPr>
@@ -16084,7 +16084,7 @@
             <a:r>
               <a:rPr sz="2200" b="1" i="0">
                 <a:solidFill>
-                  <a:srgbClr val="76B900"/>
+                  <a:srgbClr val="6B7A3F"/>
                 </a:solidFill>
                 <a:latin typeface="Arial"/>
               </a:rPr>
@@ -16103,7 +16103,7 @@
             <a:r>
               <a:rPr sz="1800" b="0" i="0">
                 <a:solidFill>
-                  <a:srgbClr val="FFFFFF"/>
+                  <a:srgbClr val="141413"/>
                 </a:solidFill>
                 <a:latin typeface="Arial"/>
               </a:rPr>
@@ -16122,7 +16122,7 @@
             <a:r>
               <a:rPr sz="1800" b="0" i="0">
                 <a:solidFill>
-                  <a:srgbClr val="FFFFFF"/>
+                  <a:srgbClr val="141413"/>
                 </a:solidFill>
                 <a:latin typeface="Arial"/>
               </a:rPr>
@@ -16141,7 +16141,7 @@
             <a:r>
               <a:rPr sz="1800" b="0" i="0">
                 <a:solidFill>
-                  <a:srgbClr val="FFFFFF"/>
+                  <a:srgbClr val="141413"/>
                 </a:solidFill>
                 <a:latin typeface="Arial"/>
               </a:rPr>
@@ -16160,7 +16160,7 @@
             <a:r>
               <a:rPr sz="1800" b="0" i="0">
                 <a:solidFill>
-                  <a:srgbClr val="FFFFFF"/>
+                  <a:srgbClr val="141413"/>
                 </a:solidFill>
                 <a:latin typeface="Arial"/>
               </a:rPr>
@@ -16179,7 +16179,7 @@
             <a:r>
               <a:rPr sz="1800" b="0" i="0">
                 <a:solidFill>
-                  <a:srgbClr val="FFFFFF"/>
+                  <a:srgbClr val="141413"/>
                 </a:solidFill>
                 <a:latin typeface="Arial"/>
               </a:rPr>
@@ -16198,7 +16198,7 @@
             <a:r>
               <a:rPr sz="1800" b="0" i="0">
                 <a:solidFill>
-                  <a:srgbClr val="FFFFFF"/>
+                  <a:srgbClr val="141413"/>
                 </a:solidFill>
                 <a:latin typeface="Arial"/>
               </a:rPr>
@@ -16221,7 +16221,7 @@
     <p:bg>
       <p:bgPr>
         <a:solidFill>
-          <a:srgbClr val="000000"/>
+          <a:srgbClr val="F5F4ED"/>
         </a:solidFill>
         <a:effectLst/>
       </p:bgPr>
@@ -16258,9 +16258,9 @@
             <a:r>
               <a:rPr sz="3200" b="1" i="0">
                 <a:solidFill>
-                  <a:srgbClr val="FFFFFF"/>
-                </a:solidFill>
-                <a:latin typeface="Arial"/>
+                  <a:srgbClr val="141413"/>
+                </a:solidFill>
+                <a:latin typeface="Georgia"/>
               </a:rPr>
               <a:t>.claude/ 是專案的「AI 大腦」 — 6 大設定觀念</a:t>
             </a:r>
@@ -16282,7 +16282,7 @@
             <a:avLst/>
           </a:prstGeom>
           <a:solidFill>
-            <a:srgbClr val="76B900"/>
+            <a:srgbClr val="C96442"/>
           </a:solidFill>
           <a:ln>
             <a:noFill/>
@@ -16344,7 +16344,7 @@
             <a:r>
               <a:rPr sz="2000" b="1" i="0">
                 <a:solidFill>
-                  <a:srgbClr val="76B900"/>
+                  <a:srgbClr val="C96442"/>
                 </a:solidFill>
                 <a:latin typeface="Arial"/>
               </a:rPr>
@@ -16363,7 +16363,7 @@
             <a:r>
               <a:rPr sz="2000" b="0" i="0">
                 <a:solidFill>
-                  <a:srgbClr val="FFFFFF"/>
+                  <a:srgbClr val="141413"/>
                 </a:solidFill>
                 <a:latin typeface="Arial"/>
               </a:rPr>
@@ -16382,7 +16382,7 @@
             <a:r>
               <a:rPr sz="2000" b="0" i="0">
                 <a:solidFill>
-                  <a:srgbClr val="FFFFFF"/>
+                  <a:srgbClr val="141413"/>
                 </a:solidFill>
                 <a:latin typeface="Arial"/>
               </a:rPr>
@@ -16401,7 +16401,7 @@
             <a:r>
               <a:rPr sz="2000" b="0" i="0">
                 <a:solidFill>
-                  <a:srgbClr val="FFFFFF"/>
+                  <a:srgbClr val="141413"/>
                 </a:solidFill>
                 <a:latin typeface="Arial"/>
               </a:rPr>
@@ -16420,7 +16420,7 @@
             <a:r>
               <a:rPr sz="2000" b="0" i="0">
                 <a:solidFill>
-                  <a:srgbClr val="FFFFFF"/>
+                  <a:srgbClr val="141413"/>
                 </a:solidFill>
                 <a:latin typeface="Arial"/>
               </a:rPr>
@@ -16439,7 +16439,7 @@
             <a:r>
               <a:rPr sz="2000" b="0" i="0">
                 <a:solidFill>
-                  <a:srgbClr val="FFFFFF"/>
+                  <a:srgbClr val="141413"/>
                 </a:solidFill>
                 <a:latin typeface="Arial"/>
               </a:rPr>
@@ -16458,7 +16458,7 @@
             <a:r>
               <a:rPr sz="2000" b="0" i="0">
                 <a:solidFill>
-                  <a:srgbClr val="FFFFFF"/>
+                  <a:srgbClr val="141413"/>
                 </a:solidFill>
                 <a:latin typeface="Arial"/>
               </a:rPr>
@@ -16477,7 +16477,7 @@
             <a:r>
               <a:rPr sz="1200" b="0" i="0">
                 <a:solidFill>
-                  <a:srgbClr val="FFFFFF"/>
+                  <a:srgbClr val="141413"/>
                 </a:solidFill>
                 <a:latin typeface="Arial"/>
               </a:rPr>
@@ -16496,7 +16496,7 @@
             <a:r>
               <a:rPr sz="1800" b="0" i="0">
                 <a:solidFill>
-                  <a:srgbClr val="898989"/>
+                  <a:srgbClr val="5E5D59"/>
                 </a:solidFill>
                 <a:latin typeface="Arial"/>
               </a:rPr>
@@ -16519,7 +16519,7 @@
     <p:bg>
       <p:bgPr>
         <a:solidFill>
-          <a:srgbClr val="000000"/>
+          <a:srgbClr val="F5F4ED"/>
         </a:solidFill>
         <a:effectLst/>
       </p:bgPr>
@@ -16556,9 +16556,9 @@
             <a:r>
               <a:rPr sz="3200" b="1" i="0">
                 <a:solidFill>
-                  <a:srgbClr val="FFFFFF"/>
-                </a:solidFill>
-                <a:latin typeface="Arial"/>
+                  <a:srgbClr val="141413"/>
+                </a:solidFill>
+                <a:latin typeface="Georgia"/>
               </a:rPr>
               <a:t>CLAUDE.md — 專案說明書</a:t>
             </a:r>
@@ -16580,7 +16580,7 @@
             <a:avLst/>
           </a:prstGeom>
           <a:solidFill>
-            <a:srgbClr val="76B900"/>
+            <a:srgbClr val="C96442"/>
           </a:solidFill>
           <a:ln>
             <a:noFill/>
@@ -16642,7 +16642,7 @@
             <a:r>
               <a:rPr sz="2000" b="1" i="0">
                 <a:solidFill>
-                  <a:srgbClr val="76B900"/>
+                  <a:srgbClr val="C96442"/>
                 </a:solidFill>
                 <a:latin typeface="Arial"/>
               </a:rPr>
@@ -16661,7 +16661,7 @@
             <a:r>
               <a:rPr sz="1800" b="0" i="0">
                 <a:solidFill>
-                  <a:srgbClr val="A7A7A7"/>
+                  <a:srgbClr val="3D3D3A"/>
                 </a:solidFill>
                 <a:latin typeface="Arial"/>
               </a:rPr>
@@ -16680,7 +16680,7 @@
             <a:r>
               <a:rPr sz="1000" b="0" i="0">
                 <a:solidFill>
-                  <a:srgbClr val="FFFFFF"/>
+                  <a:srgbClr val="141413"/>
                 </a:solidFill>
                 <a:latin typeface="Arial"/>
               </a:rPr>
@@ -16699,7 +16699,7 @@
             <a:r>
               <a:rPr sz="2000" b="1" i="0">
                 <a:solidFill>
-                  <a:srgbClr val="FFFFFF"/>
+                  <a:srgbClr val="141413"/>
                 </a:solidFill>
                 <a:latin typeface="Arial"/>
               </a:rPr>
@@ -16718,7 +16718,7 @@
             <a:r>
               <a:rPr sz="1800" b="0" i="0">
                 <a:solidFill>
-                  <a:srgbClr val="FFFFFF"/>
+                  <a:srgbClr val="141413"/>
                 </a:solidFill>
                 <a:latin typeface="Arial"/>
               </a:rPr>
@@ -16737,7 +16737,7 @@
             <a:r>
               <a:rPr sz="1800" b="0" i="0">
                 <a:solidFill>
-                  <a:srgbClr val="FFFFFF"/>
+                  <a:srgbClr val="141413"/>
                 </a:solidFill>
                 <a:latin typeface="Arial"/>
               </a:rPr>
@@ -16756,7 +16756,7 @@
             <a:r>
               <a:rPr sz="1800" b="0" i="0">
                 <a:solidFill>
-                  <a:srgbClr val="FFFFFF"/>
+                  <a:srgbClr val="141413"/>
                 </a:solidFill>
                 <a:latin typeface="Arial"/>
               </a:rPr>
@@ -16775,7 +16775,7 @@
             <a:r>
               <a:rPr sz="1800" b="0" i="0">
                 <a:solidFill>
-                  <a:srgbClr val="FFFFFF"/>
+                  <a:srgbClr val="141413"/>
                 </a:solidFill>
                 <a:latin typeface="Arial"/>
               </a:rPr>
@@ -16794,7 +16794,7 @@
             <a:r>
               <a:rPr sz="1800" b="0" i="0">
                 <a:solidFill>
-                  <a:srgbClr val="FFFFFF"/>
+                  <a:srgbClr val="141413"/>
                 </a:solidFill>
                 <a:latin typeface="Arial"/>
               </a:rPr>
@@ -16813,7 +16813,7 @@
             <a:r>
               <a:rPr sz="1000" b="0" i="0">
                 <a:solidFill>
-                  <a:srgbClr val="FFFFFF"/>
+                  <a:srgbClr val="141413"/>
                 </a:solidFill>
                 <a:latin typeface="Arial"/>
               </a:rPr>
@@ -16832,7 +16832,7 @@
             <a:r>
               <a:rPr sz="1800" b="1" i="0">
                 <a:solidFill>
-                  <a:srgbClr val="76B900"/>
+                  <a:srgbClr val="6B7A3F"/>
                 </a:solidFill>
                 <a:latin typeface="Arial"/>
               </a:rPr>
@@ -16855,7 +16855,7 @@
     <p:bg>
       <p:bgPr>
         <a:solidFill>
-          <a:srgbClr val="000000"/>
+          <a:srgbClr val="F5F4ED"/>
         </a:solidFill>
         <a:effectLst/>
       </p:bgPr>
@@ -16892,9 +16892,9 @@
             <a:r>
               <a:rPr sz="3200" b="1" i="0">
                 <a:solidFill>
-                  <a:srgbClr val="FFFFFF"/>
-                </a:solidFill>
-                <a:latin typeface="Arial"/>
+                  <a:srgbClr val="141413"/>
+                </a:solidFill>
+                <a:latin typeface="Georgia"/>
               </a:rPr>
               <a:t>rules/ — 永遠載入的規則（13 條）</a:t>
             </a:r>
@@ -16916,7 +16916,7 @@
             <a:avLst/>
           </a:prstGeom>
           <a:solidFill>
-            <a:srgbClr val="76B900"/>
+            <a:srgbClr val="C96442"/>
           </a:solidFill>
           <a:ln>
             <a:noFill/>
@@ -16978,7 +16978,7 @@
             <a:r>
               <a:rPr sz="2000" b="1" i="0">
                 <a:solidFill>
-                  <a:srgbClr val="76B900"/>
+                  <a:srgbClr val="C96442"/>
                 </a:solidFill>
                 <a:latin typeface="Arial"/>
               </a:rPr>
@@ -16997,7 +16997,7 @@
             <a:r>
               <a:rPr sz="1800" b="0" i="0">
                 <a:solidFill>
-                  <a:srgbClr val="A7A7A7"/>
+                  <a:srgbClr val="3D3D3A"/>
                 </a:solidFill>
                 <a:latin typeface="Arial"/>
               </a:rPr>
@@ -17016,7 +17016,7 @@
             <a:r>
               <a:rPr sz="1000" b="0" i="0">
                 <a:solidFill>
-                  <a:srgbClr val="FFFFFF"/>
+                  <a:srgbClr val="141413"/>
                 </a:solidFill>
                 <a:latin typeface="Arial"/>
               </a:rPr>
@@ -17035,7 +17035,7 @@
             <a:r>
               <a:rPr sz="2000" b="1" i="0">
                 <a:solidFill>
-                  <a:srgbClr val="FFFFFF"/>
+                  <a:srgbClr val="141413"/>
                 </a:solidFill>
                 <a:latin typeface="Arial"/>
               </a:rPr>
@@ -17054,7 +17054,7 @@
             <a:r>
               <a:rPr sz="1800" b="0" i="0">
                 <a:solidFill>
-                  <a:srgbClr val="FFFFFF"/>
+                  <a:srgbClr val="141413"/>
                 </a:solidFill>
                 <a:latin typeface="Arial"/>
               </a:rPr>
@@ -17073,7 +17073,7 @@
             <a:r>
               <a:rPr sz="1800" b="0" i="0">
                 <a:solidFill>
-                  <a:srgbClr val="FFFFFF"/>
+                  <a:srgbClr val="141413"/>
                 </a:solidFill>
                 <a:latin typeface="Arial"/>
               </a:rPr>
@@ -17092,7 +17092,7 @@
             <a:r>
               <a:rPr sz="1800" b="0" i="0">
                 <a:solidFill>
-                  <a:srgbClr val="FFFFFF"/>
+                  <a:srgbClr val="141413"/>
                 </a:solidFill>
                 <a:latin typeface="Arial"/>
               </a:rPr>
@@ -17111,7 +17111,7 @@
             <a:r>
               <a:rPr sz="1800" b="0" i="0">
                 <a:solidFill>
-                  <a:srgbClr val="FFFFFF"/>
+                  <a:srgbClr val="141413"/>
                 </a:solidFill>
                 <a:latin typeface="Arial"/>
               </a:rPr>
@@ -17130,7 +17130,7 @@
             <a:r>
               <a:rPr sz="1800" b="0" i="0">
                 <a:solidFill>
-                  <a:srgbClr val="FFFFFF"/>
+                  <a:srgbClr val="141413"/>
                 </a:solidFill>
                 <a:latin typeface="Arial"/>
               </a:rPr>
@@ -17149,7 +17149,7 @@
             <a:r>
               <a:rPr sz="1000" b="0" i="0">
                 <a:solidFill>
-                  <a:srgbClr val="FFFFFF"/>
+                  <a:srgbClr val="141413"/>
                 </a:solidFill>
                 <a:latin typeface="Arial"/>
               </a:rPr>
@@ -17168,7 +17168,7 @@
             <a:r>
               <a:rPr sz="1800" b="1" i="0">
                 <a:solidFill>
-                  <a:srgbClr val="76B900"/>
+                  <a:srgbClr val="6B7A3F"/>
                 </a:solidFill>
                 <a:latin typeface="Arial"/>
               </a:rPr>
@@ -17191,7 +17191,7 @@
     <p:bg>
       <p:bgPr>
         <a:solidFill>
-          <a:srgbClr val="000000"/>
+          <a:srgbClr val="F5F4ED"/>
         </a:solidFill>
         <a:effectLst/>
       </p:bgPr>
@@ -17228,9 +17228,9 @@
             <a:r>
               <a:rPr sz="3200" b="1" i="0">
                 <a:solidFill>
-                  <a:srgbClr val="FFFFFF"/>
-                </a:solidFill>
-                <a:latin typeface="Arial"/>
+                  <a:srgbClr val="141413"/>
+                </a:solidFill>
+                <a:latin typeface="Georgia"/>
               </a:rPr>
               <a:t>commands/ — 你的快捷指令（23 個）</a:t>
             </a:r>
@@ -17252,7 +17252,7 @@
             <a:avLst/>
           </a:prstGeom>
           <a:solidFill>
-            <a:srgbClr val="76B900"/>
+            <a:srgbClr val="C96442"/>
           </a:solidFill>
           <a:ln>
             <a:noFill/>
@@ -17314,7 +17314,7 @@
             <a:r>
               <a:rPr sz="2000" b="1" i="0">
                 <a:solidFill>
-                  <a:srgbClr val="76B900"/>
+                  <a:srgbClr val="C96442"/>
                 </a:solidFill>
                 <a:latin typeface="Arial"/>
               </a:rPr>
@@ -17333,7 +17333,7 @@
             <a:r>
               <a:rPr sz="1800" b="0" i="0">
                 <a:solidFill>
-                  <a:srgbClr val="A7A7A7"/>
+                  <a:srgbClr val="3D3D3A"/>
                 </a:solidFill>
                 <a:latin typeface="Arial"/>
               </a:rPr>
@@ -17352,7 +17352,7 @@
             <a:r>
               <a:rPr sz="1000" b="0" i="0">
                 <a:solidFill>
-                  <a:srgbClr val="FFFFFF"/>
+                  <a:srgbClr val="141413"/>
                 </a:solidFill>
                 <a:latin typeface="Arial"/>
               </a:rPr>
@@ -17371,7 +17371,7 @@
             <a:r>
               <a:rPr sz="1800" b="0" i="0">
                 <a:solidFill>
-                  <a:srgbClr val="FFFFFF"/>
+                  <a:srgbClr val="141413"/>
                 </a:solidFill>
                 <a:latin typeface="Arial"/>
               </a:rPr>
@@ -17390,7 +17390,7 @@
             <a:r>
               <a:rPr sz="1800" b="0" i="0">
                 <a:solidFill>
-                  <a:srgbClr val="FFFFFF"/>
+                  <a:srgbClr val="141413"/>
                 </a:solidFill>
                 <a:latin typeface="Arial"/>
               </a:rPr>
@@ -17409,7 +17409,7 @@
             <a:r>
               <a:rPr sz="1800" b="0" i="0">
                 <a:solidFill>
-                  <a:srgbClr val="FFFFFF"/>
+                  <a:srgbClr val="141413"/>
                 </a:solidFill>
                 <a:latin typeface="Arial"/>
               </a:rPr>
@@ -17428,7 +17428,7 @@
             <a:r>
               <a:rPr sz="1800" b="0" i="0">
                 <a:solidFill>
-                  <a:srgbClr val="FFFFFF"/>
+                  <a:srgbClr val="141413"/>
                 </a:solidFill>
                 <a:latin typeface="Arial"/>
               </a:rPr>
@@ -17447,7 +17447,7 @@
             <a:r>
               <a:rPr sz="1800" b="0" i="0">
                 <a:solidFill>
-                  <a:srgbClr val="FFFFFF"/>
+                  <a:srgbClr val="141413"/>
                 </a:solidFill>
                 <a:latin typeface="Arial"/>
               </a:rPr>
@@ -17466,7 +17466,7 @@
             <a:r>
               <a:rPr sz="1800" b="0" i="0">
                 <a:solidFill>
-                  <a:srgbClr val="FFFFFF"/>
+                  <a:srgbClr val="141413"/>
                 </a:solidFill>
                 <a:latin typeface="Arial"/>
               </a:rPr>
@@ -17485,7 +17485,7 @@
             <a:r>
               <a:rPr sz="1800" b="0" i="0">
                 <a:solidFill>
-                  <a:srgbClr val="898989"/>
+                  <a:srgbClr val="5E5D59"/>
                 </a:solidFill>
                 <a:latin typeface="Arial"/>
               </a:rPr>
@@ -17504,7 +17504,7 @@
             <a:r>
               <a:rPr sz="1000" b="0" i="0">
                 <a:solidFill>
-                  <a:srgbClr val="FFFFFF"/>
+                  <a:srgbClr val="141413"/>
                 </a:solidFill>
                 <a:latin typeface="Arial"/>
               </a:rPr>
@@ -17523,7 +17523,7 @@
             <a:r>
               <a:rPr sz="1800" b="1" i="0">
                 <a:solidFill>
-                  <a:srgbClr val="76B900"/>
+                  <a:srgbClr val="6B7A3F"/>
                 </a:solidFill>
                 <a:latin typeface="Arial"/>
               </a:rPr>

</xml_diff>

<commit_message>
docs(workshop): 修正投影片指令數 25→24（刪除 /statusline-style 後）
直接編輯手改版 pptx，僅改 3 處指令計數文字，保留所有手動內容與排版
</commit_message>
<xml_diff>
--- a/workshop/docs/slides/VibeCoding_Workshop.pptx
+++ b/workshop/docs/slides/VibeCoding_Workshop.pptx
@@ -11691,7 +11691,7 @@
                 <a:latin typeface="Consolas"/>
                 <a:ea typeface="Microsoft JhengHei"/>
               </a:rPr>
-              <a:t>├── commands/        ← 25 個快捷指令</a:t>
+              <a:t>├── commands/        ← 24 個快捷指令</a:t>
             </a:r>
           </a:p>
           <a:p>
@@ -31081,7 +31081,7 @@
                 <a:latin typeface="Arial"/>
                 <a:ea typeface="Microsoft JhengHei"/>
               </a:rPr>
-              <a:t>⚡  25 個快捷指令        一行啟動完整流程</a:t>
+              <a:t>⚡  24 個快捷指令        一行啟動完整流程</a:t>
             </a:r>
           </a:p>
           <a:p>
@@ -40563,7 +40563,7 @@
                 <a:latin typeface="Georgia"/>
                 <a:ea typeface="Microsoft JhengHei"/>
               </a:rPr>
-              <a:t>commands/ — 你的快捷指令（25 個）</a:t>
+              <a:t>commands/ — 你的快捷指令（24 個）</a:t>
             </a:r>
           </a:p>
         </p:txBody>

</xml_diff>